<commit_message>
docs: technical architecture slide in deck
Co-Authored-By: Claude Fable 5 <noreply@anthropic.com>
</commit_message>
<xml_diff>
--- a/docs/deck/agent-fight-city.pptx
+++ b/docs/deck/agent-fight-city.pptx
@@ -1908,8 +1908,8 @@
         </p:nvSpPr>
         <p:spPr>
           <a:xfrm>
-            <a:off x="640080" y="365760"/>
-            <a:ext cx="10972800" cy="640080"/>
+            <a:off x="548640" y="228600"/>
+            <a:ext cx="10972800" cy="548640"/>
           </a:xfrm>
           <a:prstGeom prst="rect">
             <a:avLst/>
@@ -1925,7 +1925,7 @@
               <a:buNone/>
             </a:pPr>
             <a:r>
-              <a:rPr lang="en-US" sz="3200" b="1" dirty="0">
+              <a:rPr lang="en-US" sz="3000" b="1" dirty="0">
                 <a:solidFill>
                   <a:srgbClr val="DFE6FF"/>
                 </a:solidFill>
@@ -1933,9 +1933,9 @@
                 <a:ea typeface="Arial" pitchFamily="34" charset="-122"/>
                 <a:cs typeface="Arial" pitchFamily="34" charset="-120"/>
               </a:rPr>
-              <a:t>How a fight flows</a:t>
-            </a:r>
-            <a:endParaRPr lang="en-US" sz="3200" dirty="0"/>
+              <a:t>Architecture</a:t>
+            </a:r>
+            <a:endParaRPr lang="en-US" sz="3000" dirty="0"/>
           </a:p>
         </p:txBody>
       </p:sp>
@@ -1947,18 +1947,18 @@
         </p:nvSpPr>
         <p:spPr>
           <a:xfrm>
-            <a:off x="640080" y="1828800"/>
-            <a:ext cx="2514600" cy="2286000"/>
+            <a:off x="548640" y="1005840"/>
+            <a:ext cx="2743200" cy="2286000"/>
           </a:xfrm>
           <a:prstGeom prst="roundRect">
             <a:avLst>
-              <a:gd name="adj" fmla="val 4800"/>
+              <a:gd name="adj" fmla="val 3200"/>
             </a:avLst>
           </a:prstGeom>
           <a:solidFill>
             <a:srgbClr val="141A2E"/>
           </a:solidFill>
-          <a:ln w="19050">
+          <a:ln w="15875">
             <a:solidFill>
               <a:srgbClr val="7EC8FF"/>
             </a:solidFill>
@@ -1974,8 +1974,8 @@
         </p:nvSpPr>
         <p:spPr>
           <a:xfrm>
-            <a:off x="777240" y="2148840"/>
-            <a:ext cx="2240280" cy="548640"/>
+            <a:off x="685800" y="1143000"/>
+            <a:ext cx="2468880" cy="320040"/>
           </a:xfrm>
           <a:prstGeom prst="rect">
             <a:avLst/>
@@ -1991,7 +1991,7 @@
               <a:buNone/>
             </a:pPr>
             <a:r>
-              <a:rPr lang="en-US" sz="2100" b="1" dirty="0">
+              <a:rPr lang="en-US" sz="1500" b="1" dirty="0">
                 <a:solidFill>
                   <a:srgbClr val="7EC8FF"/>
                 </a:solidFill>
@@ -1999,9 +1999,9 @@
                 <a:ea typeface="Arial" pitchFamily="34" charset="-122"/>
                 <a:cs typeface="Arial" pitchFamily="34" charset="-120"/>
               </a:rPr>
-              <a:t>Bright Data</a:t>
-            </a:r>
-            <a:endParaRPr lang="en-US" sz="2100" dirty="0"/>
+              <a:t>BROWSER</a:t>
+            </a:r>
+            <a:endParaRPr lang="en-US" sz="1500" dirty="0"/>
           </a:p>
         </p:txBody>
       </p:sp>
@@ -2013,8 +2013,8 @@
         </p:nvSpPr>
         <p:spPr>
           <a:xfrm>
-            <a:off x="777240" y="2788920"/>
-            <a:ext cx="2240280" cy="1097280"/>
+            <a:off x="685800" y="1600200"/>
+            <a:ext cx="2468880" cy="1463040"/>
           </a:xfrm>
           <a:prstGeom prst="rect">
             <a:avLst/>
@@ -2030,7 +2030,7 @@
               <a:buNone/>
             </a:pPr>
             <a:r>
-              <a:rPr lang="en-US" sz="1350" dirty="0">
+              <a:rPr lang="en-US" sz="1250" dirty="0">
                 <a:solidFill>
                   <a:srgbClr val="DFE6FF"/>
                 </a:solidFill>
@@ -2038,16 +2038,16 @@
                 <a:ea typeface="Arial" pitchFamily="34" charset="-122"/>
                 <a:cs typeface="Arial" pitchFamily="34" charset="-120"/>
               </a:rPr>
-              <a:t>scrapes live GitHub —</a:t>
-            </a:r>
-            <a:endParaRPr lang="en-US" sz="1350" dirty="0"/>
-          </a:p>
-          <a:p>
-            <a:pPr algn="ctr" indent="0" marL="0">
-              <a:buNone/>
-            </a:pPr>
-            <a:r>
-              <a:rPr lang="en-US" sz="1350" dirty="0">
+              <a:t>Three.js city + HUD</a:t>
+            </a:r>
+            <a:endParaRPr lang="en-US" sz="1250" dirty="0"/>
+          </a:p>
+          <a:p>
+            <a:pPr algn="ctr" indent="0" marL="0">
+              <a:buNone/>
+            </a:pPr>
+            <a:r>
+              <a:rPr lang="en-US" sz="1250" dirty="0">
                 <a:solidFill>
                   <a:srgbClr val="DFE6FF"/>
                 </a:solidFill>
@@ -2055,71 +2055,348 @@
                 <a:ea typeface="Arial" pitchFamily="34" charset="-122"/>
                 <a:cs typeface="Arial" pitchFamily="34" charset="-120"/>
               </a:rPr>
-              <a:t>the skyline IS the data</a:t>
-            </a:r>
-            <a:endParaRPr lang="en-US" sz="1350" dirty="0"/>
-          </a:p>
-        </p:txBody>
-      </p:sp>
-      <p:sp>
-        <p:nvSpPr>
-          <p:cNvPr id="6" name="Text 4"/>
-          <p:cNvSpPr txBox="1"/>
-          <p:nvPr/>
-        </p:nvSpPr>
-        <p:spPr>
-          <a:xfrm>
-            <a:off x="3172968" y="2651760"/>
-            <a:ext cx="411480" cy="640080"/>
-          </a:xfrm>
-          <a:prstGeom prst="rect">
-            <a:avLst/>
-          </a:prstGeom>
-          <a:noFill/>
-          <a:ln/>
-        </p:spPr>
-        <p:txBody>
-          <a:bodyPr wrap="square" lIns="0" tIns="0" rIns="0" bIns="0" rtlCol="0" anchor="ctr"/>
-          <a:lstStyle/>
-          <a:p>
-            <a:pPr algn="ctr" indent="0" marL="0">
-              <a:buNone/>
-            </a:pPr>
-            <a:r>
-              <a:rPr lang="en-US" sz="2600" b="1" dirty="0">
-                <a:solidFill>
-                  <a:srgbClr val="8B96C2"/>
-                </a:solidFill>
-                <a:latin typeface="Arial" pitchFamily="34" charset="0"/>
-                <a:ea typeface="Arial" pitchFamily="34" charset="-122"/>
-                <a:cs typeface="Arial" pitchFamily="34" charset="-120"/>
-              </a:rPr>
-              <a:t>→</a:t>
-            </a:r>
-            <a:endParaRPr lang="en-US" sz="2600" dirty="0"/>
-          </a:p>
-        </p:txBody>
-      </p:sp>
-      <p:sp>
-        <p:nvSpPr>
-          <p:cNvPr id="7" name="Shape 5"/>
+              <a:t>replay scrubber</a:t>
+            </a:r>
+            <a:endParaRPr lang="en-US" sz="1250" dirty="0"/>
+          </a:p>
+          <a:p>
+            <a:pPr algn="ctr" indent="0" marL="0">
+              <a:buNone/>
+            </a:pPr>
+            <a:r>
+              <a:rPr lang="en-US" sz="1250" dirty="0">
+                <a:solidFill>
+                  <a:srgbClr val="DFE6FF"/>
+                </a:solidFill>
+                <a:latin typeface="Arial" pitchFamily="34" charset="0"/>
+                <a:ea typeface="Arial" pitchFamily="34" charset="-122"/>
+                <a:cs typeface="Arial" pitchFamily="34" charset="-120"/>
+              </a:rPr>
+              <a:t>zero fight logic —</a:t>
+            </a:r>
+            <a:endParaRPr lang="en-US" sz="1250" dirty="0"/>
+          </a:p>
+          <a:p>
+            <a:pPr algn="ctr" indent="0" marL="0">
+              <a:buNone/>
+            </a:pPr>
+            <a:r>
+              <a:rPr lang="en-US" sz="1250" dirty="0">
+                <a:solidFill>
+                  <a:srgbClr val="DFE6FF"/>
+                </a:solidFill>
+                <a:latin typeface="Arial" pitchFamily="34" charset="0"/>
+                <a:ea typeface="Arial" pitchFamily="34" charset="-122"/>
+                <a:cs typeface="Arial" pitchFamily="34" charset="-120"/>
+              </a:rPr>
+              <a:t>renders 10 event types</a:t>
+            </a:r>
+            <a:endParaRPr lang="en-US" sz="1250" dirty="0"/>
+          </a:p>
+        </p:txBody>
+      </p:sp>
+      <p:sp>
+        <p:nvSpPr>
+          <p:cNvPr id="6" name="Shape 4"/>
           <p:cNvSpPr/>
           <p:nvPr/>
         </p:nvSpPr>
         <p:spPr>
           <a:xfrm>
-            <a:off x="3566160" y="1828800"/>
-            <a:ext cx="2514600" cy="2286000"/>
+            <a:off x="4480560" y="1005840"/>
+            <a:ext cx="3108960" cy="2286000"/>
           </a:xfrm>
           <a:prstGeom prst="roundRect">
             <a:avLst>
-              <a:gd name="adj" fmla="val 4800"/>
+              <a:gd name="adj" fmla="val 3200"/>
             </a:avLst>
           </a:prstGeom>
           <a:solidFill>
             <a:srgbClr val="141A2E"/>
           </a:solidFill>
+          <a:ln w="15875">
+            <a:solidFill>
+              <a:srgbClr val="6FE3A1"/>
+            </a:solidFill>
+            <a:prstDash val="solid"/>
+          </a:ln>
+        </p:spPr>
+      </p:sp>
+      <p:sp>
+        <p:nvSpPr>
+          <p:cNvPr id="7" name="Text 5"/>
+          <p:cNvSpPr txBox="1"/>
+          <p:nvPr/>
+        </p:nvSpPr>
+        <p:spPr>
+          <a:xfrm>
+            <a:off x="4617720" y="1143000"/>
+            <a:ext cx="2834640" cy="320040"/>
+          </a:xfrm>
+          <a:prstGeom prst="rect">
+            <a:avLst/>
+          </a:prstGeom>
+          <a:noFill/>
+          <a:ln/>
+        </p:spPr>
+        <p:txBody>
+          <a:bodyPr wrap="square" lIns="0" tIns="0" rIns="0" bIns="0" rtlCol="0" anchor="ctr"/>
+          <a:lstStyle/>
+          <a:p>
+            <a:pPr algn="ctr" indent="0" marL="0">
+              <a:buNone/>
+            </a:pPr>
+            <a:r>
+              <a:rPr lang="en-US" sz="1500" b="1" dirty="0">
+                <a:solidFill>
+                  <a:srgbClr val="6FE3A1"/>
+                </a:solidFill>
+                <a:latin typeface="Arial" pitchFamily="34" charset="0"/>
+                <a:ea typeface="Arial" pitchFamily="34" charset="-122"/>
+                <a:cs typeface="Arial" pitchFamily="34" charset="-120"/>
+              </a:rPr>
+              <a:t>FastAPI SERVER</a:t>
+            </a:r>
+            <a:endParaRPr lang="en-US" sz="1500" dirty="0"/>
+          </a:p>
+        </p:txBody>
+      </p:sp>
+      <p:sp>
+        <p:nvSpPr>
+          <p:cNvPr id="8" name="Text 6"/>
+          <p:cNvSpPr txBox="1"/>
+          <p:nvPr/>
+        </p:nvSpPr>
+        <p:spPr>
+          <a:xfrm>
+            <a:off x="4617720" y="1600200"/>
+            <a:ext cx="2834640" cy="1463040"/>
+          </a:xfrm>
+          <a:prstGeom prst="rect">
+            <a:avLst/>
+          </a:prstGeom>
+          <a:noFill/>
+          <a:ln/>
+        </p:spPr>
+        <p:txBody>
+          <a:bodyPr wrap="square" lIns="0" tIns="0" rIns="0" bIns="0" rtlCol="0" anchor="ctr"/>
+          <a:lstStyle/>
+          <a:p>
+            <a:pPr algn="ctr" indent="0" marL="0">
+              <a:buNone/>
+            </a:pPr>
+            <a:r>
+              <a:rPr lang="en-US" sz="1250" dirty="0">
+                <a:solidFill>
+                  <a:srgbClr val="DFE6FF"/>
+                </a:solidFill>
+                <a:latin typeface="Arial" pitchFamily="34" charset="0"/>
+                <a:ea typeface="Arial" pitchFamily="34" charset="-122"/>
+                <a:cs typeface="Arial" pitchFamily="34" charset="-120"/>
+              </a:rPr>
+              <a:t>POST /fight  →  session</a:t>
+            </a:r>
+            <a:endParaRPr lang="en-US" sz="1250" dirty="0"/>
+          </a:p>
+          <a:p>
+            <a:pPr algn="ctr" indent="0" marL="0">
+              <a:buNone/>
+            </a:pPr>
+            <a:r>
+              <a:rPr lang="en-US" sz="1250" dirty="0">
+                <a:solidFill>
+                  <a:srgbClr val="DFE6FF"/>
+                </a:solidFill>
+                <a:latin typeface="Arial" pitchFamily="34" charset="0"/>
+                <a:ea typeface="Arial" pitchFamily="34" charset="-122"/>
+                <a:cs typeface="Arial" pitchFamily="34" charset="-120"/>
+              </a:rPr>
+              <a:t>GET /events  (SSE)</a:t>
+            </a:r>
+            <a:endParaRPr lang="en-US" sz="1250" dirty="0"/>
+          </a:p>
+          <a:p>
+            <a:pPr algn="ctr" indent="0" marL="0">
+              <a:buNone/>
+            </a:pPr>
+            <a:r>
+              <a:rPr lang="en-US" sz="1250" dirty="0">
+                <a:solidFill>
+                  <a:srgbClr val="DFE6FF"/>
+                </a:solidFill>
+                <a:latin typeface="Arial" pitchFamily="34" charset="0"/>
+                <a:ea typeface="Arial" pitchFamily="34" charset="-122"/>
+                <a:cs typeface="Arial" pitchFamily="34" charset="-120"/>
+              </a:rPr>
+              <a:t>GET /repos · /stats</a:t>
+            </a:r>
+            <a:endParaRPr lang="en-US" sz="1250" dirty="0"/>
+          </a:p>
+          <a:p>
+            <a:pPr algn="ctr" indent="0" marL="0">
+              <a:buNone/>
+            </a:pPr>
+            <a:r>
+              <a:rPr lang="en-US" sz="1250" dirty="0">
+                <a:solidFill>
+                  <a:srgbClr val="DFE6FF"/>
+                </a:solidFill>
+                <a:latin typeface="Arial" pitchFamily="34" charset="0"/>
+                <a:ea typeface="Arial" pitchFamily="34" charset="-122"/>
+                <a:cs typeface="Arial" pitchFamily="34" charset="-120"/>
+              </a:rPr>
+              <a:t>"a dumb pipe, on purpose"</a:t>
+            </a:r>
+            <a:endParaRPr lang="en-US" sz="1250" dirty="0"/>
+          </a:p>
+        </p:txBody>
+      </p:sp>
+      <p:sp>
+        <p:nvSpPr>
+          <p:cNvPr id="9" name="Shape 7"/>
+          <p:cNvSpPr/>
+          <p:nvPr/>
+        </p:nvSpPr>
+        <p:spPr>
+          <a:xfrm>
+            <a:off x="3291840" y="1737360"/>
+            <a:ext cx="1188720" cy="0"/>
+          </a:xfrm>
+          <a:prstGeom prst="line">
+            <a:avLst/>
+          </a:prstGeom>
+          <a:noFill/>
           <a:ln w="19050">
+            <a:solidFill>
+              <a:srgbClr val="8B96C2"/>
+            </a:solidFill>
+            <a:prstDash val="solid"/>
+            <a:tailEnd type="triangle"/>
+          </a:ln>
+        </p:spPr>
+      </p:sp>
+      <p:sp>
+        <p:nvSpPr>
+          <p:cNvPr id="10" name="Text 8"/>
+          <p:cNvSpPr txBox="1"/>
+          <p:nvPr/>
+        </p:nvSpPr>
+        <p:spPr>
+          <a:xfrm>
+            <a:off x="3246120" y="1417320"/>
+            <a:ext cx="1280160" cy="320040"/>
+          </a:xfrm>
+          <a:prstGeom prst="rect">
+            <a:avLst/>
+          </a:prstGeom>
+          <a:noFill/>
+          <a:ln/>
+        </p:spPr>
+        <p:txBody>
+          <a:bodyPr wrap="square" lIns="0" tIns="0" rIns="0" bIns="0" rtlCol="0" anchor="ctr"/>
+          <a:lstStyle/>
+          <a:p>
+            <a:pPr algn="ctr" indent="0" marL="0">
+              <a:buNone/>
+            </a:pPr>
+            <a:r>
+              <a:rPr lang="en-US" sz="1050" i="1" dirty="0">
+                <a:solidFill>
+                  <a:srgbClr val="8B96C2"/>
+                </a:solidFill>
+                <a:latin typeface="Cambria" pitchFamily="34" charset="0"/>
+                <a:ea typeface="Cambria" pitchFamily="34" charset="-122"/>
+                <a:cs typeface="Cambria" pitchFamily="34" charset="-120"/>
+              </a:rPr>
+              <a:t>POST /fight</a:t>
+            </a:r>
+            <a:endParaRPr lang="en-US" sz="1050" dirty="0"/>
+          </a:p>
+        </p:txBody>
+      </p:sp>
+      <p:sp>
+        <p:nvSpPr>
+          <p:cNvPr id="11" name="Shape 9"/>
+          <p:cNvSpPr/>
+          <p:nvPr/>
+        </p:nvSpPr>
+        <p:spPr>
+          <a:xfrm flipH="1">
+            <a:off x="4480560" y="2514600"/>
+            <a:ext cx="1188720" cy="0"/>
+          </a:xfrm>
+          <a:prstGeom prst="line">
+            <a:avLst/>
+          </a:prstGeom>
+          <a:noFill/>
+          <a:ln w="19050">
+            <a:solidFill>
+              <a:srgbClr val="8B96C2"/>
+            </a:solidFill>
+            <a:prstDash val="solid"/>
+            <a:tailEnd type="triangle"/>
+          </a:ln>
+        </p:spPr>
+      </p:sp>
+      <p:sp>
+        <p:nvSpPr>
+          <p:cNvPr id="12" name="Text 10"/>
+          <p:cNvSpPr txBox="1"/>
+          <p:nvPr/>
+        </p:nvSpPr>
+        <p:spPr>
+          <a:xfrm>
+            <a:off x="3108960" y="2651760"/>
+            <a:ext cx="1554480" cy="320040"/>
+          </a:xfrm>
+          <a:prstGeom prst="rect">
+            <a:avLst/>
+          </a:prstGeom>
+          <a:noFill/>
+          <a:ln/>
+        </p:spPr>
+        <p:txBody>
+          <a:bodyPr wrap="square" lIns="0" tIns="0" rIns="0" bIns="0" rtlCol="0" anchor="ctr"/>
+          <a:lstStyle/>
+          <a:p>
+            <a:pPr algn="ctr" indent="0" marL="0">
+              <a:buNone/>
+            </a:pPr>
+            <a:r>
+              <a:rPr lang="en-US" sz="1050" i="1" dirty="0">
+                <a:solidFill>
+                  <a:srgbClr val="8B96C2"/>
+                </a:solidFill>
+                <a:latin typeface="Cambria" pitchFamily="34" charset="0"/>
+                <a:ea typeface="Cambria" pitchFamily="34" charset="-122"/>
+                <a:cs typeface="Cambria" pitchFamily="34" charset="-120"/>
+              </a:rPr>
+              <a:t>SSE event stream</a:t>
+            </a:r>
+            <a:endParaRPr lang="en-US" sz="1050" dirty="0"/>
+          </a:p>
+        </p:txBody>
+      </p:sp>
+      <p:sp>
+        <p:nvSpPr>
+          <p:cNvPr id="13" name="Shape 11"/>
+          <p:cNvSpPr/>
+          <p:nvPr/>
+        </p:nvSpPr>
+        <p:spPr>
+          <a:xfrm>
+            <a:off x="3383280" y="3794760"/>
+            <a:ext cx="5394960" cy="2651760"/>
+          </a:xfrm>
+          <a:prstGeom prst="roundRect">
+            <a:avLst>
+              <a:gd name="adj" fmla="val 2759"/>
+            </a:avLst>
+          </a:prstGeom>
+          <a:solidFill>
+            <a:srgbClr val="141A2E"/>
+          </a:solidFill>
+          <a:ln w="15875">
             <a:solidFill>
               <a:srgbClr val="FFB347"/>
             </a:solidFill>
@@ -2129,14 +2406,14 @@
       </p:sp>
       <p:sp>
         <p:nvSpPr>
-          <p:cNvPr id="8" name="Text 6"/>
+          <p:cNvPr id="14" name="Text 12"/>
           <p:cNvSpPr txBox="1"/>
           <p:nvPr/>
         </p:nvSpPr>
         <p:spPr>
           <a:xfrm>
-            <a:off x="3703320" y="2148840"/>
-            <a:ext cx="2240280" cy="548640"/>
+            <a:off x="3520440" y="3913632"/>
+            <a:ext cx="5120640" cy="320040"/>
           </a:xfrm>
           <a:prstGeom prst="rect">
             <a:avLst/>
@@ -2152,7 +2429,7 @@
               <a:buNone/>
             </a:pPr>
             <a:r>
-              <a:rPr lang="en-US" sz="2100" b="1" dirty="0">
+              <a:rPr lang="en-US" sz="1300" b="1" dirty="0">
                 <a:solidFill>
                   <a:srgbClr val="FFB347"/>
                 </a:solidFill>
@@ -2160,127 +2437,344 @@
                 <a:ea typeface="Arial" pitchFamily="34" charset="-122"/>
                 <a:cs typeface="Arial" pitchFamily="34" charset="-120"/>
               </a:rPr>
-              <a:t>TrueFoundry</a:t>
-            </a:r>
-            <a:endParaRPr lang="en-US" sz="2100" dirty="0"/>
-          </a:p>
-        </p:txBody>
-      </p:sp>
-      <p:sp>
-        <p:nvSpPr>
-          <p:cNvPr id="9" name="Text 7"/>
-          <p:cNvSpPr txBox="1"/>
-          <p:nvPr/>
-        </p:nvSpPr>
-        <p:spPr>
-          <a:xfrm>
-            <a:off x="3703320" y="2788920"/>
-            <a:ext cx="2240280" cy="1097280"/>
-          </a:xfrm>
-          <a:prstGeom prst="rect">
-            <a:avLst/>
-          </a:prstGeom>
-          <a:noFill/>
-          <a:ln/>
-        </p:spPr>
-        <p:txBody>
-          <a:bodyPr wrap="square" lIns="0" tIns="0" rIns="0" bIns="0" rtlCol="0" anchor="ctr"/>
-          <a:lstStyle/>
-          <a:p>
-            <a:pPr algn="ctr" indent="0" marL="0">
-              <a:buNone/>
-            </a:pPr>
-            <a:r>
-              <a:rPr lang="en-US" sz="1350" dirty="0">
-                <a:solidFill>
-                  <a:srgbClr val="DFE6FF"/>
-                </a:solidFill>
-                <a:latin typeface="Arial" pitchFamily="34" charset="0"/>
-                <a:ea typeface="Arial" pitchFamily="34" charset="-122"/>
-                <a:cs typeface="Arial" pitchFamily="34" charset="-120"/>
-              </a:rPr>
-              <a:t>AI gateway runs the</a:t>
-            </a:r>
-            <a:endParaRPr lang="en-US" sz="1350" dirty="0"/>
-          </a:p>
-          <a:p>
-            <a:pPr algn="ctr" indent="0" marL="0">
-              <a:buNone/>
-            </a:pPr>
-            <a:r>
-              <a:rPr lang="en-US" sz="1350" dirty="0">
-                <a:solidFill>
-                  <a:srgbClr val="DFE6FF"/>
-                </a:solidFill>
-                <a:latin typeface="Arial" pitchFamily="34" charset="0"/>
-                <a:ea typeface="Arial" pitchFamily="34" charset="-122"/>
-                <a:cs typeface="Arial" pitchFamily="34" charset="-120"/>
-              </a:rPr>
-              <a:t>fighter + referee agents</a:t>
-            </a:r>
-            <a:endParaRPr lang="en-US" sz="1350" dirty="0"/>
-          </a:p>
-        </p:txBody>
-      </p:sp>
-      <p:sp>
-        <p:nvSpPr>
-          <p:cNvPr id="10" name="Text 8"/>
-          <p:cNvSpPr txBox="1"/>
-          <p:nvPr/>
-        </p:nvSpPr>
-        <p:spPr>
-          <a:xfrm>
-            <a:off x="6099048" y="2651760"/>
-            <a:ext cx="411480" cy="640080"/>
-          </a:xfrm>
-          <a:prstGeom prst="rect">
-            <a:avLst/>
-          </a:prstGeom>
-          <a:noFill/>
-          <a:ln/>
-        </p:spPr>
-        <p:txBody>
-          <a:bodyPr wrap="square" lIns="0" tIns="0" rIns="0" bIns="0" rtlCol="0" anchor="ctr"/>
-          <a:lstStyle/>
-          <a:p>
-            <a:pPr algn="ctr" indent="0" marL="0">
-              <a:buNone/>
-            </a:pPr>
-            <a:r>
-              <a:rPr lang="en-US" sz="2600" b="1" dirty="0">
-                <a:solidFill>
-                  <a:srgbClr val="8B96C2"/>
-                </a:solidFill>
-                <a:latin typeface="Arial" pitchFamily="34" charset="0"/>
-                <a:ea typeface="Arial" pitchFamily="34" charset="-122"/>
-                <a:cs typeface="Arial" pitchFamily="34" charset="-120"/>
-              </a:rPr>
-              <a:t>→</a:t>
-            </a:r>
-            <a:endParaRPr lang="en-US" sz="2600" dirty="0"/>
-          </a:p>
-        </p:txBody>
-      </p:sp>
-      <p:sp>
-        <p:nvSpPr>
-          <p:cNvPr id="11" name="Shape 9"/>
+              <a:t>FIGHT HARNESS  (python subprocess · emits JSONL on stdout)</a:t>
+            </a:r>
+            <a:endParaRPr lang="en-US" sz="1300" dirty="0"/>
+          </a:p>
+        </p:txBody>
+      </p:sp>
+      <p:sp>
+        <p:nvSpPr>
+          <p:cNvPr id="15" name="Shape 13"/>
           <p:cNvSpPr/>
           <p:nvPr/>
         </p:nvSpPr>
         <p:spPr>
           <a:xfrm>
-            <a:off x="6492240" y="1828800"/>
-            <a:ext cx="2514600" cy="2286000"/>
+            <a:off x="3611880" y="4434840"/>
+            <a:ext cx="1600200" cy="1783080"/>
           </a:xfrm>
           <a:prstGeom prst="roundRect">
             <a:avLst>
-              <a:gd name="adj" fmla="val 4800"/>
+              <a:gd name="adj" fmla="val 4571"/>
             </a:avLst>
           </a:prstGeom>
           <a:solidFill>
             <a:srgbClr val="141A2E"/>
           </a:solidFill>
-          <a:ln w="19050">
+          <a:ln w="15875">
+            <a:solidFill>
+              <a:srgbClr val="FFB347"/>
+            </a:solidFill>
+            <a:prstDash val="solid"/>
+          </a:ln>
+        </p:spPr>
+      </p:sp>
+      <p:sp>
+        <p:nvSpPr>
+          <p:cNvPr id="16" name="Text 14"/>
+          <p:cNvSpPr txBox="1"/>
+          <p:nvPr/>
+        </p:nvSpPr>
+        <p:spPr>
+          <a:xfrm>
+            <a:off x="3657600" y="4526280"/>
+            <a:ext cx="1508760" cy="320040"/>
+          </a:xfrm>
+          <a:prstGeom prst="rect">
+            <a:avLst/>
+          </a:prstGeom>
+          <a:noFill/>
+          <a:ln/>
+        </p:spPr>
+        <p:txBody>
+          <a:bodyPr wrap="square" lIns="0" tIns="0" rIns="0" bIns="0" rtlCol="0" anchor="ctr"/>
+          <a:lstStyle/>
+          <a:p>
+            <a:pPr algn="ctr" indent="0" marL="0">
+              <a:buNone/>
+            </a:pPr>
+            <a:r>
+              <a:rPr lang="en-US" sz="1200" b="1" dirty="0">
+                <a:solidFill>
+                  <a:srgbClr val="FFB347"/>
+                </a:solidFill>
+                <a:latin typeface="Arial" pitchFamily="34" charset="0"/>
+                <a:ea typeface="Arial" pitchFamily="34" charset="-122"/>
+                <a:cs typeface="Arial" pitchFamily="34" charset="-120"/>
+              </a:rPr>
+              <a:t>FIGHTER A</a:t>
+            </a:r>
+            <a:endParaRPr lang="en-US" sz="1200" dirty="0"/>
+          </a:p>
+        </p:txBody>
+      </p:sp>
+      <p:sp>
+        <p:nvSpPr>
+          <p:cNvPr id="17" name="Text 15"/>
+          <p:cNvSpPr txBox="1"/>
+          <p:nvPr/>
+        </p:nvSpPr>
+        <p:spPr>
+          <a:xfrm>
+            <a:off x="3657600" y="4864608"/>
+            <a:ext cx="1508760" cy="1234440"/>
+          </a:xfrm>
+          <a:prstGeom prst="rect">
+            <a:avLst/>
+          </a:prstGeom>
+          <a:noFill/>
+          <a:ln/>
+        </p:spPr>
+        <p:txBody>
+          <a:bodyPr wrap="square" lIns="0" tIns="0" rIns="0" bIns="0" rtlCol="0" anchor="ctr"/>
+          <a:lstStyle/>
+          <a:p>
+            <a:pPr algn="ctr" indent="0" marL="0">
+              <a:buNone/>
+            </a:pPr>
+            <a:r>
+              <a:rPr lang="en-US" sz="1050" dirty="0">
+                <a:solidFill>
+                  <a:srgbClr val="DFE6FF"/>
+                </a:solidFill>
+                <a:latin typeface="Arial" pitchFamily="34" charset="0"/>
+                <a:ea typeface="Arial" pitchFamily="34" charset="-122"/>
+                <a:cs typeface="Arial" pitchFamily="34" charset="-120"/>
+              </a:rPr>
+              <a:t>sandbox clone</a:t>
+            </a:r>
+            <a:endParaRPr lang="en-US" sz="1050" dirty="0"/>
+          </a:p>
+          <a:p>
+            <a:pPr algn="ctr" indent="0" marL="0">
+              <a:buNone/>
+            </a:pPr>
+            <a:r>
+              <a:rPr lang="en-US" sz="1050" dirty="0">
+                <a:solidFill>
+                  <a:srgbClr val="DFE6FF"/>
+                </a:solidFill>
+                <a:latin typeface="Arial" pitchFamily="34" charset="0"/>
+                <a:ea typeface="Arial" pitchFamily="34" charset="-122"/>
+                <a:cs typeface="Arial" pitchFamily="34" charset="-120"/>
+              </a:rPr>
+              <a:t>branch fight/a</a:t>
+            </a:r>
+            <a:endParaRPr lang="en-US" sz="1050" dirty="0"/>
+          </a:p>
+          <a:p>
+            <a:pPr algn="ctr" indent="0" marL="0">
+              <a:buNone/>
+            </a:pPr>
+            <a:r>
+              <a:rPr lang="en-US" sz="1050" dirty="0">
+                <a:solidFill>
+                  <a:srgbClr val="DFE6FF"/>
+                </a:solidFill>
+                <a:latin typeface="Arial" pitchFamily="34" charset="0"/>
+                <a:ea typeface="Arial" pitchFamily="34" charset="-122"/>
+                <a:cs typeface="Arial" pitchFamily="34" charset="-120"/>
+              </a:rPr>
+              <a:t>TrueFoundry</a:t>
+            </a:r>
+            <a:endParaRPr lang="en-US" sz="1050" dirty="0"/>
+          </a:p>
+          <a:p>
+            <a:pPr algn="ctr" indent="0" marL="0">
+              <a:buNone/>
+            </a:pPr>
+            <a:r>
+              <a:rPr lang="en-US" sz="1050" dirty="0">
+                <a:solidFill>
+                  <a:srgbClr val="DFE6FF"/>
+                </a:solidFill>
+                <a:latin typeface="Arial" pitchFamily="34" charset="0"/>
+                <a:ea typeface="Arial" pitchFamily="34" charset="-122"/>
+                <a:cs typeface="Arial" pitchFamily="34" charset="-120"/>
+              </a:rPr>
+              <a:t>gateway</a:t>
+            </a:r>
+            <a:endParaRPr lang="en-US" sz="1050" dirty="0"/>
+          </a:p>
+        </p:txBody>
+      </p:sp>
+      <p:sp>
+        <p:nvSpPr>
+          <p:cNvPr id="18" name="Shape 16"/>
+          <p:cNvSpPr/>
+          <p:nvPr/>
+        </p:nvSpPr>
+        <p:spPr>
+          <a:xfrm>
+            <a:off x="5303520" y="4434840"/>
+            <a:ext cx="1600200" cy="1783080"/>
+          </a:xfrm>
+          <a:prstGeom prst="roundRect">
+            <a:avLst>
+              <a:gd name="adj" fmla="val 4571"/>
+            </a:avLst>
+          </a:prstGeom>
+          <a:solidFill>
+            <a:srgbClr val="141A2E"/>
+          </a:solidFill>
+          <a:ln w="15875">
+            <a:solidFill>
+              <a:srgbClr val="7EC8FF"/>
+            </a:solidFill>
+            <a:prstDash val="solid"/>
+          </a:ln>
+        </p:spPr>
+      </p:sp>
+      <p:sp>
+        <p:nvSpPr>
+          <p:cNvPr id="19" name="Text 17"/>
+          <p:cNvSpPr txBox="1"/>
+          <p:nvPr/>
+        </p:nvSpPr>
+        <p:spPr>
+          <a:xfrm>
+            <a:off x="5349240" y="4526280"/>
+            <a:ext cx="1508760" cy="320040"/>
+          </a:xfrm>
+          <a:prstGeom prst="rect">
+            <a:avLst/>
+          </a:prstGeom>
+          <a:noFill/>
+          <a:ln/>
+        </p:spPr>
+        <p:txBody>
+          <a:bodyPr wrap="square" lIns="0" tIns="0" rIns="0" bIns="0" rtlCol="0" anchor="ctr"/>
+          <a:lstStyle/>
+          <a:p>
+            <a:pPr algn="ctr" indent="0" marL="0">
+              <a:buNone/>
+            </a:pPr>
+            <a:r>
+              <a:rPr lang="en-US" sz="1200" b="1" dirty="0">
+                <a:solidFill>
+                  <a:srgbClr val="7EC8FF"/>
+                </a:solidFill>
+                <a:latin typeface="Arial" pitchFamily="34" charset="0"/>
+                <a:ea typeface="Arial" pitchFamily="34" charset="-122"/>
+                <a:cs typeface="Arial" pitchFamily="34" charset="-120"/>
+              </a:rPr>
+              <a:t>FIGHTER B</a:t>
+            </a:r>
+            <a:endParaRPr lang="en-US" sz="1200" dirty="0"/>
+          </a:p>
+        </p:txBody>
+      </p:sp>
+      <p:sp>
+        <p:nvSpPr>
+          <p:cNvPr id="20" name="Text 18"/>
+          <p:cNvSpPr txBox="1"/>
+          <p:nvPr/>
+        </p:nvSpPr>
+        <p:spPr>
+          <a:xfrm>
+            <a:off x="5349240" y="4864608"/>
+            <a:ext cx="1508760" cy="1234440"/>
+          </a:xfrm>
+          <a:prstGeom prst="rect">
+            <a:avLst/>
+          </a:prstGeom>
+          <a:noFill/>
+          <a:ln/>
+        </p:spPr>
+        <p:txBody>
+          <a:bodyPr wrap="square" lIns="0" tIns="0" rIns="0" bIns="0" rtlCol="0" anchor="ctr"/>
+          <a:lstStyle/>
+          <a:p>
+            <a:pPr algn="ctr" indent="0" marL="0">
+              <a:buNone/>
+            </a:pPr>
+            <a:r>
+              <a:rPr lang="en-US" sz="1050" dirty="0">
+                <a:solidFill>
+                  <a:srgbClr val="DFE6FF"/>
+                </a:solidFill>
+                <a:latin typeface="Arial" pitchFamily="34" charset="0"/>
+                <a:ea typeface="Arial" pitchFamily="34" charset="-122"/>
+                <a:cs typeface="Arial" pitchFamily="34" charset="-120"/>
+              </a:rPr>
+              <a:t>sandbox clone</a:t>
+            </a:r>
+            <a:endParaRPr lang="en-US" sz="1050" dirty="0"/>
+          </a:p>
+          <a:p>
+            <a:pPr algn="ctr" indent="0" marL="0">
+              <a:buNone/>
+            </a:pPr>
+            <a:r>
+              <a:rPr lang="en-US" sz="1050" dirty="0">
+                <a:solidFill>
+                  <a:srgbClr val="DFE6FF"/>
+                </a:solidFill>
+                <a:latin typeface="Arial" pitchFamily="34" charset="0"/>
+                <a:ea typeface="Arial" pitchFamily="34" charset="-122"/>
+                <a:cs typeface="Arial" pitchFamily="34" charset="-120"/>
+              </a:rPr>
+              <a:t>branch fight/b</a:t>
+            </a:r>
+            <a:endParaRPr lang="en-US" sz="1050" dirty="0"/>
+          </a:p>
+          <a:p>
+            <a:pPr algn="ctr" indent="0" marL="0">
+              <a:buNone/>
+            </a:pPr>
+            <a:r>
+              <a:rPr lang="en-US" sz="1050" dirty="0">
+                <a:solidFill>
+                  <a:srgbClr val="DFE6FF"/>
+                </a:solidFill>
+                <a:latin typeface="Arial" pitchFamily="34" charset="0"/>
+                <a:ea typeface="Arial" pitchFamily="34" charset="-122"/>
+                <a:cs typeface="Arial" pitchFamily="34" charset="-120"/>
+              </a:rPr>
+              <a:t>OpenAI /</a:t>
+            </a:r>
+            <a:endParaRPr lang="en-US" sz="1050" dirty="0"/>
+          </a:p>
+          <a:p>
+            <a:pPr algn="ctr" indent="0" marL="0">
+              <a:buNone/>
+            </a:pPr>
+            <a:r>
+              <a:rPr lang="en-US" sz="1050" dirty="0">
+                <a:solidFill>
+                  <a:srgbClr val="DFE6FF"/>
+                </a:solidFill>
+                <a:latin typeface="Arial" pitchFamily="34" charset="0"/>
+                <a:ea typeface="Arial" pitchFamily="34" charset="-122"/>
+                <a:cs typeface="Arial" pitchFamily="34" charset="-120"/>
+              </a:rPr>
+              <a:t>Gemini Vertex</a:t>
+            </a:r>
+            <a:endParaRPr lang="en-US" sz="1050" dirty="0"/>
+          </a:p>
+        </p:txBody>
+      </p:sp>
+      <p:sp>
+        <p:nvSpPr>
+          <p:cNvPr id="21" name="Shape 19"/>
+          <p:cNvSpPr/>
+          <p:nvPr/>
+        </p:nvSpPr>
+        <p:spPr>
+          <a:xfrm>
+            <a:off x="6995160" y="4434840"/>
+            <a:ext cx="1600200" cy="1783080"/>
+          </a:xfrm>
+          <a:prstGeom prst="roundRect">
+            <a:avLst>
+              <a:gd name="adj" fmla="val 4571"/>
+            </a:avLst>
+          </a:prstGeom>
+          <a:solidFill>
+            <a:srgbClr val="141A2E"/>
+          </a:solidFill>
+          <a:ln w="15875">
             <a:solidFill>
               <a:srgbClr val="C9A5FF"/>
             </a:solidFill>
@@ -2290,14 +2784,14 @@
       </p:sp>
       <p:sp>
         <p:nvSpPr>
-          <p:cNvPr id="12" name="Text 10"/>
+          <p:cNvPr id="22" name="Text 20"/>
           <p:cNvSpPr txBox="1"/>
           <p:nvPr/>
         </p:nvSpPr>
         <p:spPr>
           <a:xfrm>
-            <a:off x="6629400" y="2148840"/>
-            <a:ext cx="2240280" cy="548640"/>
+            <a:off x="7040880" y="4526280"/>
+            <a:ext cx="1508760" cy="320040"/>
           </a:xfrm>
           <a:prstGeom prst="rect">
             <a:avLst/>
@@ -2313,7 +2807,7 @@
               <a:buNone/>
             </a:pPr>
             <a:r>
-              <a:rPr lang="en-US" sz="2100" b="1" dirty="0">
+              <a:rPr lang="en-US" sz="1200" b="1" dirty="0">
                 <a:solidFill>
                   <a:srgbClr val="C9A5FF"/>
                 </a:solidFill>
@@ -2321,22 +2815,22 @@
                 <a:ea typeface="Arial" pitchFamily="34" charset="-122"/>
                 <a:cs typeface="Arial" pitchFamily="34" charset="-120"/>
               </a:rPr>
-              <a:t>Qodo</a:t>
-            </a:r>
-            <a:endParaRPr lang="en-US" sz="2100" dirty="0"/>
-          </a:p>
-        </p:txBody>
-      </p:sp>
-      <p:sp>
-        <p:nvSpPr>
-          <p:cNvPr id="13" name="Text 11"/>
+              <a:t>REFEREE</a:t>
+            </a:r>
+            <a:endParaRPr lang="en-US" sz="1200" dirty="0"/>
+          </a:p>
+        </p:txBody>
+      </p:sp>
+      <p:sp>
+        <p:nvSpPr>
+          <p:cNvPr id="23" name="Text 21"/>
           <p:cNvSpPr txBox="1"/>
           <p:nvPr/>
         </p:nvSpPr>
         <p:spPr>
           <a:xfrm>
-            <a:off x="6629400" y="2788920"/>
-            <a:ext cx="2240280" cy="1097280"/>
+            <a:off x="7040880" y="4864608"/>
+            <a:ext cx="1508760" cy="1234440"/>
           </a:xfrm>
           <a:prstGeom prst="rect">
             <a:avLst/>
@@ -2352,7 +2846,7 @@
               <a:buNone/>
             </a:pPr>
             <a:r>
-              <a:rPr lang="en-US" sz="1350" dirty="0">
+              <a:rPr lang="en-US" sz="1050" dirty="0">
                 <a:solidFill>
                   <a:srgbClr val="DFE6FF"/>
                 </a:solidFill>
@@ -2360,16 +2854,16 @@
                 <a:ea typeface="Arial" pitchFamily="34" charset="-122"/>
                 <a:cs typeface="Arial" pitchFamily="34" charset="-120"/>
               </a:rPr>
-              <a:t>review gates every PR —</a:t>
-            </a:r>
-            <a:endParaRPr lang="en-US" sz="1350" dirty="0"/>
-          </a:p>
-          <a:p>
-            <a:pPr algn="ctr" indent="0" marL="0">
-              <a:buNone/>
-            </a:pPr>
-            <a:r>
-              <a:rPr lang="en-US" sz="1350" dirty="0">
+              <a:t>clean 4th clone</a:t>
+            </a:r>
+            <a:endParaRPr lang="en-US" sz="1050" dirty="0"/>
+          </a:p>
+          <a:p>
+            <a:pPr algn="ctr" indent="0" marL="0">
+              <a:buNone/>
+            </a:pPr>
+            <a:r>
+              <a:rPr lang="en-US" sz="1050" dirty="0">
                 <a:solidFill>
                   <a:srgbClr val="DFE6FF"/>
                 </a:solidFill>
@@ -2377,22 +2871,80 @@
                 <a:ea typeface="Arial" pitchFamily="34" charset="-122"/>
                 <a:cs typeface="Arial" pitchFamily="34" charset="-120"/>
               </a:rPr>
-              <a:t>ours and the referee’s</a:t>
-            </a:r>
-            <a:endParaRPr lang="en-US" sz="1350" dirty="0"/>
-          </a:p>
-        </p:txBody>
-      </p:sp>
-      <p:sp>
-        <p:nvSpPr>
-          <p:cNvPr id="14" name="Text 12"/>
+              <a:t>re-runs MAIN's</a:t>
+            </a:r>
+            <a:endParaRPr lang="en-US" sz="1050" dirty="0"/>
+          </a:p>
+          <a:p>
+            <a:pPr algn="ctr" indent="0" marL="0">
+              <a:buNone/>
+            </a:pPr>
+            <a:r>
+              <a:rPr lang="en-US" sz="1050" dirty="0">
+                <a:solidFill>
+                  <a:srgbClr val="DFE6FF"/>
+                </a:solidFill>
+                <a:latin typeface="Arial" pitchFamily="34" charset="0"/>
+                <a:ea typeface="Arial" pitchFamily="34" charset="-122"/>
+                <a:cs typeface="Arial" pitchFamily="34" charset="-120"/>
+              </a:rPr>
+              <a:t>tests · reviews</a:t>
+            </a:r>
+            <a:endParaRPr lang="en-US" sz="1050" dirty="0"/>
+          </a:p>
+          <a:p>
+            <a:pPr algn="ctr" indent="0" marL="0">
+              <a:buNone/>
+            </a:pPr>
+            <a:r>
+              <a:rPr lang="en-US" sz="1050" dirty="0">
+                <a:solidFill>
+                  <a:srgbClr val="DFE6FF"/>
+                </a:solidFill>
+                <a:latin typeface="Arial" pitchFamily="34" charset="0"/>
+                <a:ea typeface="Arial" pitchFamily="34" charset="-122"/>
+                <a:cs typeface="Arial" pitchFamily="34" charset="-120"/>
+              </a:rPr>
+              <a:t>diffs · scores</a:t>
+            </a:r>
+            <a:endParaRPr lang="en-US" sz="1050" dirty="0"/>
+          </a:p>
+        </p:txBody>
+      </p:sp>
+      <p:sp>
+        <p:nvSpPr>
+          <p:cNvPr id="24" name="Shape 22"/>
+          <p:cNvSpPr/>
+          <p:nvPr/>
+        </p:nvSpPr>
+        <p:spPr>
+          <a:xfrm>
+            <a:off x="6035040" y="3291840"/>
+            <a:ext cx="0" cy="502920"/>
+          </a:xfrm>
+          <a:prstGeom prst="line">
+            <a:avLst/>
+          </a:prstGeom>
+          <a:noFill/>
+          <a:ln w="19050">
+            <a:solidFill>
+              <a:srgbClr val="8B96C2"/>
+            </a:solidFill>
+            <a:prstDash val="solid"/>
+            <a:tailEnd type="triangle"/>
+          </a:ln>
+        </p:spPr>
+      </p:sp>
+      <p:sp>
+        <p:nvSpPr>
+          <p:cNvPr id="25" name="Text 23"/>
           <p:cNvSpPr txBox="1"/>
           <p:nvPr/>
         </p:nvSpPr>
         <p:spPr>
           <a:xfrm>
-            <a:off x="9025128" y="2651760"/>
-            <a:ext cx="411480" cy="640080"/>
+            <a:off x="6172200" y="3310128"/>
+            <a:ext cx="1828800" cy="320040"/>
           </a:xfrm>
           <a:prstGeom prst="rect">
             <a:avLst/>
@@ -2408,40 +2960,40 @@
               <a:buNone/>
             </a:pPr>
             <a:r>
-              <a:rPr lang="en-US" sz="2600" b="1" dirty="0">
+              <a:rPr lang="en-US" sz="1050" i="1" dirty="0">
                 <a:solidFill>
                   <a:srgbClr val="8B96C2"/>
                 </a:solidFill>
-                <a:latin typeface="Arial" pitchFamily="34" charset="0"/>
-                <a:ea typeface="Arial" pitchFamily="34" charset="-122"/>
-                <a:cs typeface="Arial" pitchFamily="34" charset="-120"/>
-              </a:rPr>
-              <a:t>→</a:t>
-            </a:r>
-            <a:endParaRPr lang="en-US" sz="2600" dirty="0"/>
-          </a:p>
-        </p:txBody>
-      </p:sp>
-      <p:sp>
-        <p:nvSpPr>
-          <p:cNvPr id="15" name="Shape 13"/>
+                <a:latin typeface="Cambria" pitchFamily="34" charset="0"/>
+                <a:ea typeface="Cambria" pitchFamily="34" charset="-122"/>
+                <a:cs typeface="Cambria" pitchFamily="34" charset="-120"/>
+              </a:rPr>
+              <a:t>spawn · pipe stdout</a:t>
+            </a:r>
+            <a:endParaRPr lang="en-US" sz="1050" dirty="0"/>
+          </a:p>
+        </p:txBody>
+      </p:sp>
+      <p:sp>
+        <p:nvSpPr>
+          <p:cNvPr id="26" name="Shape 24"/>
           <p:cNvSpPr/>
           <p:nvPr/>
         </p:nvSpPr>
         <p:spPr>
           <a:xfrm>
-            <a:off x="9418320" y="1828800"/>
-            <a:ext cx="2514600" cy="2286000"/>
+            <a:off x="9418320" y="868680"/>
+            <a:ext cx="2240280" cy="1371600"/>
           </a:xfrm>
           <a:prstGeom prst="roundRect">
             <a:avLst>
-              <a:gd name="adj" fmla="val 4800"/>
+              <a:gd name="adj" fmla="val 5333"/>
             </a:avLst>
           </a:prstGeom>
           <a:solidFill>
             <a:srgbClr val="141A2E"/>
           </a:solidFill>
-          <a:ln w="19050">
+          <a:ln w="15875">
             <a:solidFill>
               <a:srgbClr val="6FE3A1"/>
             </a:solidFill>
@@ -2451,14 +3003,14 @@
       </p:sp>
       <p:sp>
         <p:nvSpPr>
-          <p:cNvPr id="16" name="Text 14"/>
+          <p:cNvPr id="27" name="Text 25"/>
           <p:cNvSpPr txBox="1"/>
           <p:nvPr/>
         </p:nvSpPr>
         <p:spPr>
           <a:xfrm>
-            <a:off x="9555480" y="2148840"/>
-            <a:ext cx="2240280" cy="548640"/>
+            <a:off x="9509760" y="969264"/>
+            <a:ext cx="2057400" cy="320040"/>
           </a:xfrm>
           <a:prstGeom prst="rect">
             <a:avLst/>
@@ -2474,7 +3026,7 @@
               <a:buNone/>
             </a:pPr>
             <a:r>
-              <a:rPr lang="en-US" sz="2100" b="1" dirty="0">
+              <a:rPr lang="en-US" sz="1300" b="1" dirty="0">
                 <a:solidFill>
                   <a:srgbClr val="6FE3A1"/>
                 </a:solidFill>
@@ -2482,22 +3034,22 @@
                 <a:ea typeface="Arial" pitchFamily="34" charset="-122"/>
                 <a:cs typeface="Arial" pitchFamily="34" charset="-120"/>
               </a:rPr>
-              <a:t>GitHub</a:t>
-            </a:r>
-            <a:endParaRPr lang="en-US" sz="2100" dirty="0"/>
-          </a:p>
-        </p:txBody>
-      </p:sp>
-      <p:sp>
-        <p:nvSpPr>
-          <p:cNvPr id="17" name="Text 15"/>
+              <a:t>GITHUB</a:t>
+            </a:r>
+            <a:endParaRPr lang="en-US" sz="1300" dirty="0"/>
+          </a:p>
+        </p:txBody>
+      </p:sp>
+      <p:sp>
+        <p:nvSpPr>
+          <p:cNvPr id="28" name="Text 26"/>
           <p:cNvSpPr txBox="1"/>
           <p:nvPr/>
         </p:nvSpPr>
         <p:spPr>
           <a:xfrm>
-            <a:off x="9555480" y="2788920"/>
-            <a:ext cx="2240280" cy="1097280"/>
+            <a:off x="9509760" y="1325880"/>
+            <a:ext cx="2057400" cy="731520"/>
           </a:xfrm>
           <a:prstGeom prst="rect">
             <a:avLst/>
@@ -2513,7 +3065,7 @@
               <a:buNone/>
             </a:pPr>
             <a:r>
-              <a:rPr lang="en-US" sz="1350" dirty="0">
+              <a:rPr lang="en-US" sz="1100" dirty="0">
                 <a:solidFill>
                   <a:srgbClr val="DFE6FF"/>
                 </a:solidFill>
@@ -2521,16 +3073,16 @@
                 <a:ea typeface="Arial" pitchFamily="34" charset="-122"/>
                 <a:cs typeface="Arial" pitchFamily="34" charset="-120"/>
               </a:rPr>
-              <a:t>winner’s PR opens,</a:t>
-            </a:r>
-            <a:endParaRPr lang="en-US" sz="1350" dirty="0"/>
-          </a:p>
-          <a:p>
-            <a:pPr algn="ctr" indent="0" marL="0">
-              <a:buNone/>
-            </a:pPr>
-            <a:r>
-              <a:rPr lang="en-US" sz="1350" dirty="0">
+              <a:t>winner's PR opened</a:t>
+            </a:r>
+            <a:endParaRPr lang="en-US" sz="1100" dirty="0"/>
+          </a:p>
+          <a:p>
+            <a:pPr algn="ctr" indent="0" marL="0">
+              <a:buNone/>
+            </a:pPr>
+            <a:r>
+              <a:rPr lang="en-US" sz="1100" dirty="0">
                 <a:solidFill>
                   <a:srgbClr val="DFE6FF"/>
                 </a:solidFill>
@@ -2538,22 +3090,49 @@
                 <a:ea typeface="Arial" pitchFamily="34" charset="-122"/>
                 <a:cs typeface="Arial" pitchFamily="34" charset="-120"/>
               </a:rPr>
-              <a:t>loser’s branch deleted</a:t>
-            </a:r>
-            <a:endParaRPr lang="en-US" sz="1350" dirty="0"/>
-          </a:p>
-        </p:txBody>
-      </p:sp>
-      <p:sp>
-        <p:nvSpPr>
-          <p:cNvPr id="18" name="Text 16"/>
+              <a:t>loser's branch deleted</a:t>
+            </a:r>
+            <a:endParaRPr lang="en-US" sz="1100" dirty="0"/>
+          </a:p>
+        </p:txBody>
+      </p:sp>
+      <p:sp>
+        <p:nvSpPr>
+          <p:cNvPr id="29" name="Shape 27"/>
+          <p:cNvSpPr/>
+          <p:nvPr/>
+        </p:nvSpPr>
+        <p:spPr>
+          <a:xfrm>
+            <a:off x="9418320" y="2514600"/>
+            <a:ext cx="2240280" cy="1371600"/>
+          </a:xfrm>
+          <a:prstGeom prst="roundRect">
+            <a:avLst>
+              <a:gd name="adj" fmla="val 5333"/>
+            </a:avLst>
+          </a:prstGeom>
+          <a:solidFill>
+            <a:srgbClr val="141A2E"/>
+          </a:solidFill>
+          <a:ln w="15875">
+            <a:solidFill>
+              <a:srgbClr val="7EC8FF"/>
+            </a:solidFill>
+            <a:prstDash val="solid"/>
+          </a:ln>
+        </p:spPr>
+      </p:sp>
+      <p:sp>
+        <p:nvSpPr>
+          <p:cNvPr id="30" name="Text 28"/>
           <p:cNvSpPr txBox="1"/>
           <p:nvPr/>
         </p:nvSpPr>
         <p:spPr>
           <a:xfrm>
-            <a:off x="640080" y="4846320"/>
-            <a:ext cx="10972800" cy="457200"/>
+            <a:off x="9509760" y="2615184"/>
+            <a:ext cx="2057400" cy="320040"/>
           </a:xfrm>
           <a:prstGeom prst="rect">
             <a:avLst/>
@@ -2569,140 +3148,489 @@
               <a:buNone/>
             </a:pPr>
             <a:r>
-              <a:rPr lang="en-US" sz="1500" dirty="0">
+              <a:rPr lang="en-US" sz="1300" b="1" dirty="0">
+                <a:solidFill>
+                  <a:srgbClr val="7EC8FF"/>
+                </a:solidFill>
+                <a:latin typeface="Arial" pitchFamily="34" charset="0"/>
+                <a:ea typeface="Arial" pitchFamily="34" charset="-122"/>
+                <a:cs typeface="Arial" pitchFamily="34" charset="-120"/>
+              </a:rPr>
+              <a:t>BRIGHT DATA</a:t>
+            </a:r>
+            <a:endParaRPr lang="en-US" sz="1300" dirty="0"/>
+          </a:p>
+        </p:txBody>
+      </p:sp>
+      <p:sp>
+        <p:nvSpPr>
+          <p:cNvPr id="31" name="Text 29"/>
+          <p:cNvSpPr txBox="1"/>
+          <p:nvPr/>
+        </p:nvSpPr>
+        <p:spPr>
+          <a:xfrm>
+            <a:off x="9509760" y="2971800"/>
+            <a:ext cx="2057400" cy="731520"/>
+          </a:xfrm>
+          <a:prstGeom prst="rect">
+            <a:avLst/>
+          </a:prstGeom>
+          <a:noFill/>
+          <a:ln/>
+        </p:spPr>
+        <p:txBody>
+          <a:bodyPr wrap="square" lIns="0" tIns="0" rIns="0" bIns="0" rtlCol="0" anchor="ctr"/>
+          <a:lstStyle/>
+          <a:p>
+            <a:pPr algn="ctr" indent="0" marL="0">
+              <a:buNone/>
+            </a:pPr>
+            <a:r>
+              <a:rPr lang="en-US" sz="1100" dirty="0">
+                <a:solidFill>
+                  <a:srgbClr val="DFE6FF"/>
+                </a:solidFill>
+                <a:latin typeface="Arial" pitchFamily="34" charset="0"/>
+                <a:ea typeface="Arial" pitchFamily="34" charset="-122"/>
+                <a:cs typeface="Arial" pitchFamily="34" charset="-120"/>
+              </a:rPr>
+              <a:t>Web Unlocker scrapes</a:t>
+            </a:r>
+            <a:endParaRPr lang="en-US" sz="1100" dirty="0"/>
+          </a:p>
+          <a:p>
+            <a:pPr algn="ctr" indent="0" marL="0">
+              <a:buNone/>
+            </a:pPr>
+            <a:r>
+              <a:rPr lang="en-US" sz="1100" dirty="0">
+                <a:solidFill>
+                  <a:srgbClr val="DFE6FF"/>
+                </a:solidFill>
+                <a:latin typeface="Arial" pitchFamily="34" charset="0"/>
+                <a:ea typeface="Arial" pitchFamily="34" charset="-122"/>
+                <a:cs typeface="Arial" pitchFamily="34" charset="-120"/>
+              </a:rPr>
+              <a:t>GitHub → repos.json</a:t>
+            </a:r>
+            <a:endParaRPr lang="en-US" sz="1100" dirty="0"/>
+          </a:p>
+        </p:txBody>
+      </p:sp>
+      <p:sp>
+        <p:nvSpPr>
+          <p:cNvPr id="32" name="Shape 30"/>
+          <p:cNvSpPr/>
+          <p:nvPr/>
+        </p:nvSpPr>
+        <p:spPr>
+          <a:xfrm>
+            <a:off x="9418320" y="4160520"/>
+            <a:ext cx="2240280" cy="1371600"/>
+          </a:xfrm>
+          <a:prstGeom prst="roundRect">
+            <a:avLst>
+              <a:gd name="adj" fmla="val 5333"/>
+            </a:avLst>
+          </a:prstGeom>
+          <a:solidFill>
+            <a:srgbClr val="141A2E"/>
+          </a:solidFill>
+          <a:ln w="15875">
+            <a:solidFill>
+              <a:srgbClr val="FFB347"/>
+            </a:solidFill>
+            <a:prstDash val="solid"/>
+          </a:ln>
+        </p:spPr>
+      </p:sp>
+      <p:sp>
+        <p:nvSpPr>
+          <p:cNvPr id="33" name="Text 31"/>
+          <p:cNvSpPr txBox="1"/>
+          <p:nvPr/>
+        </p:nvSpPr>
+        <p:spPr>
+          <a:xfrm>
+            <a:off x="9509760" y="4261104"/>
+            <a:ext cx="2057400" cy="320040"/>
+          </a:xfrm>
+          <a:prstGeom prst="rect">
+            <a:avLst/>
+          </a:prstGeom>
+          <a:noFill/>
+          <a:ln/>
+        </p:spPr>
+        <p:txBody>
+          <a:bodyPr wrap="square" lIns="0" tIns="0" rIns="0" bIns="0" rtlCol="0" anchor="ctr"/>
+          <a:lstStyle/>
+          <a:p>
+            <a:pPr algn="ctr" indent="0" marL="0">
+              <a:buNone/>
+            </a:pPr>
+            <a:r>
+              <a:rPr lang="en-US" sz="1300" b="1" dirty="0">
+                <a:solidFill>
+                  <a:srgbClr val="FFB347"/>
+                </a:solidFill>
+                <a:latin typeface="Arial" pitchFamily="34" charset="0"/>
+                <a:ea typeface="Arial" pitchFamily="34" charset="-122"/>
+                <a:cs typeface="Arial" pitchFamily="34" charset="-120"/>
+              </a:rPr>
+              <a:t>CLICKHOUSE</a:t>
+            </a:r>
+            <a:endParaRPr lang="en-US" sz="1300" dirty="0"/>
+          </a:p>
+        </p:txBody>
+      </p:sp>
+      <p:sp>
+        <p:nvSpPr>
+          <p:cNvPr id="34" name="Text 32"/>
+          <p:cNvSpPr txBox="1"/>
+          <p:nvPr/>
+        </p:nvSpPr>
+        <p:spPr>
+          <a:xfrm>
+            <a:off x="9509760" y="4617720"/>
+            <a:ext cx="2057400" cy="731520"/>
+          </a:xfrm>
+          <a:prstGeom prst="rect">
+            <a:avLst/>
+          </a:prstGeom>
+          <a:noFill/>
+          <a:ln/>
+        </p:spPr>
+        <p:txBody>
+          <a:bodyPr wrap="square" lIns="0" tIns="0" rIns="0" bIns="0" rtlCol="0" anchor="ctr"/>
+          <a:lstStyle/>
+          <a:p>
+            <a:pPr algn="ctr" indent="0" marL="0">
+              <a:buNone/>
+            </a:pPr>
+            <a:r>
+              <a:rPr lang="en-US" sz="1100" dirty="0">
+                <a:solidFill>
+                  <a:srgbClr val="DFE6FF"/>
+                </a:solidFill>
+                <a:latin typeface="Arial" pitchFamily="34" charset="0"/>
+                <a:ea typeface="Arial" pitchFamily="34" charset="-122"/>
+                <a:cs typeface="Arial" pitchFamily="34" charset="-120"/>
+              </a:rPr>
+              <a:t>every event inserted</a:t>
+            </a:r>
+            <a:endParaRPr lang="en-US" sz="1100" dirty="0"/>
+          </a:p>
+          <a:p>
+            <a:pPr algn="ctr" indent="0" marL="0">
+              <a:buNone/>
+            </a:pPr>
+            <a:r>
+              <a:rPr lang="en-US" sz="1100" dirty="0">
+                <a:solidFill>
+                  <a:srgbClr val="DFE6FF"/>
+                </a:solidFill>
+                <a:latin typeface="Arial" pitchFamily="34" charset="0"/>
+                <a:ea typeface="Arial" pitchFamily="34" charset="-122"/>
+                <a:cs typeface="Arial" pitchFamily="34" charset="-120"/>
+              </a:rPr>
+              <a:t>JSONEachRow · /stats</a:t>
+            </a:r>
+            <a:endParaRPr lang="en-US" sz="1100" dirty="0"/>
+          </a:p>
+        </p:txBody>
+      </p:sp>
+      <p:sp>
+        <p:nvSpPr>
+          <p:cNvPr id="35" name="Shape 33"/>
+          <p:cNvSpPr/>
+          <p:nvPr/>
+        </p:nvSpPr>
+        <p:spPr>
+          <a:xfrm>
+            <a:off x="9418320" y="5806440"/>
+            <a:ext cx="2240280" cy="777240"/>
+          </a:xfrm>
+          <a:prstGeom prst="roundRect">
+            <a:avLst>
+              <a:gd name="adj" fmla="val 9412"/>
+            </a:avLst>
+          </a:prstGeom>
+          <a:solidFill>
+            <a:srgbClr val="141A2E"/>
+          </a:solidFill>
+          <a:ln w="15875">
+            <a:solidFill>
+              <a:srgbClr val="C9A5FF"/>
+            </a:solidFill>
+            <a:prstDash val="solid"/>
+          </a:ln>
+        </p:spPr>
+      </p:sp>
+      <p:sp>
+        <p:nvSpPr>
+          <p:cNvPr id="36" name="Text 34"/>
+          <p:cNvSpPr txBox="1"/>
+          <p:nvPr/>
+        </p:nvSpPr>
+        <p:spPr>
+          <a:xfrm>
+            <a:off x="9509760" y="5888736"/>
+            <a:ext cx="2057400" cy="320040"/>
+          </a:xfrm>
+          <a:prstGeom prst="rect">
+            <a:avLst/>
+          </a:prstGeom>
+          <a:noFill/>
+          <a:ln/>
+        </p:spPr>
+        <p:txBody>
+          <a:bodyPr wrap="square" lIns="0" tIns="0" rIns="0" bIns="0" rtlCol="0" anchor="ctr"/>
+          <a:lstStyle/>
+          <a:p>
+            <a:pPr algn="ctr" indent="0" marL="0">
+              <a:buNone/>
+            </a:pPr>
+            <a:r>
+              <a:rPr lang="en-US" sz="1300" b="1" dirty="0">
+                <a:solidFill>
+                  <a:srgbClr val="C9A5FF"/>
+                </a:solidFill>
+                <a:latin typeface="Arial" pitchFamily="34" charset="0"/>
+                <a:ea typeface="Arial" pitchFamily="34" charset="-122"/>
+                <a:cs typeface="Arial" pitchFamily="34" charset="-120"/>
+              </a:rPr>
+              <a:t>QODO</a:t>
+            </a:r>
+            <a:endParaRPr lang="en-US" sz="1300" dirty="0"/>
+          </a:p>
+        </p:txBody>
+      </p:sp>
+      <p:sp>
+        <p:nvSpPr>
+          <p:cNvPr id="37" name="Text 35"/>
+          <p:cNvSpPr txBox="1"/>
+          <p:nvPr/>
+        </p:nvSpPr>
+        <p:spPr>
+          <a:xfrm>
+            <a:off x="9509760" y="6217920"/>
+            <a:ext cx="2057400" cy="320040"/>
+          </a:xfrm>
+          <a:prstGeom prst="rect">
+            <a:avLst/>
+          </a:prstGeom>
+          <a:noFill/>
+          <a:ln/>
+        </p:spPr>
+        <p:txBody>
+          <a:bodyPr wrap="square" lIns="0" tIns="0" rIns="0" bIns="0" rtlCol="0" anchor="ctr"/>
+          <a:lstStyle/>
+          <a:p>
+            <a:pPr algn="ctr" indent="0" marL="0">
+              <a:buNone/>
+            </a:pPr>
+            <a:r>
+              <a:rPr lang="en-US" sz="1050" dirty="0">
+                <a:solidFill>
+                  <a:srgbClr val="DFE6FF"/>
+                </a:solidFill>
+                <a:latin typeface="Arial" pitchFamily="34" charset="0"/>
+                <a:ea typeface="Arial" pitchFamily="34" charset="-122"/>
+                <a:cs typeface="Arial" pitchFamily="34" charset="-120"/>
+              </a:rPr>
+              <a:t>reviews every PR merged</a:t>
+            </a:r>
+            <a:endParaRPr lang="en-US" sz="1050" dirty="0"/>
+          </a:p>
+        </p:txBody>
+      </p:sp>
+      <p:sp>
+        <p:nvSpPr>
+          <p:cNvPr id="38" name="Shape 36"/>
+          <p:cNvSpPr/>
+          <p:nvPr/>
+        </p:nvSpPr>
+        <p:spPr>
+          <a:xfrm>
+            <a:off x="8778240" y="5029200"/>
+            <a:ext cx="640080" cy="-3291840"/>
+          </a:xfrm>
+          <a:prstGeom prst="line">
+            <a:avLst/>
+          </a:prstGeom>
+          <a:noFill/>
+          <a:ln w="19050">
+            <a:solidFill>
+              <a:srgbClr val="8B96C2"/>
+            </a:solidFill>
+            <a:prstDash val="solid"/>
+            <a:tailEnd type="triangle"/>
+          </a:ln>
+        </p:spPr>
+      </p:sp>
+      <p:sp>
+        <p:nvSpPr>
+          <p:cNvPr id="39" name="Text 37"/>
+          <p:cNvSpPr txBox="1"/>
+          <p:nvPr/>
+        </p:nvSpPr>
+        <p:spPr>
+          <a:xfrm>
+            <a:off x="7818120" y="3657600"/>
+            <a:ext cx="1920240" cy="320040"/>
+          </a:xfrm>
+          <a:prstGeom prst="rect">
+            <a:avLst/>
+          </a:prstGeom>
+          <a:noFill/>
+          <a:ln/>
+        </p:spPr>
+        <p:txBody>
+          <a:bodyPr wrap="square" lIns="0" tIns="0" rIns="0" bIns="0" rtlCol="0" anchor="ctr"/>
+          <a:lstStyle/>
+          <a:p>
+            <a:pPr algn="ctr" indent="0" marL="0">
+              <a:buNone/>
+            </a:pPr>
+            <a:r>
+              <a:rPr lang="en-US" sz="1050" i="1" dirty="0">
                 <a:solidFill>
                   <a:srgbClr val="8B96C2"/>
-                </a:solidFill>
-                <a:latin typeface="Arial" pitchFamily="34" charset="0"/>
-                <a:ea typeface="Arial" pitchFamily="34" charset="-122"/>
-                <a:cs typeface="Arial" pitchFamily="34" charset="-120"/>
-              </a:rPr>
-              <a:t>plus  </a:t>
-            </a:r>
-            <a:pPr algn="ctr" indent="0" marL="0">
-              <a:buNone/>
-            </a:pPr>
-            <a:r>
-              <a:rPr lang="en-US" sz="1500" b="1" dirty="0">
-                <a:solidFill>
-                  <a:srgbClr val="DFE6FF"/>
-                </a:solidFill>
-                <a:latin typeface="Arial" pitchFamily="34" charset="0"/>
-                <a:ea typeface="Arial" pitchFamily="34" charset="-122"/>
-                <a:cs typeface="Arial" pitchFamily="34" charset="-120"/>
-              </a:rPr>
-              <a:t>ClickHouse Cloud</a:t>
-            </a:r>
-            <a:pPr algn="ctr" indent="0" marL="0">
-              <a:buNone/>
-            </a:pPr>
-            <a:r>
-              <a:rPr lang="en-US" sz="1500" dirty="0">
-                <a:solidFill>
-                  <a:srgbClr val="8B96C2"/>
-                </a:solidFill>
-                <a:latin typeface="Arial" pitchFamily="34" charset="0"/>
-                <a:ea typeface="Arial" pitchFamily="34" charset="-122"/>
-                <a:cs typeface="Arial" pitchFamily="34" charset="-120"/>
-              </a:rPr>
-              <a:t>  for every fight event  ·  </a:t>
-            </a:r>
-            <a:pPr algn="ctr" indent="0" marL="0">
-              <a:buNone/>
-            </a:pPr>
-            <a:r>
-              <a:rPr lang="en-US" sz="1500" b="1" dirty="0">
-                <a:solidFill>
-                  <a:srgbClr val="DFE6FF"/>
-                </a:solidFill>
-                <a:latin typeface="Arial" pitchFamily="34" charset="0"/>
-                <a:ea typeface="Arial" pitchFamily="34" charset="-122"/>
-                <a:cs typeface="Arial" pitchFamily="34" charset="-120"/>
-              </a:rPr>
-              <a:t>Vercel</a:t>
-            </a:r>
-            <a:pPr algn="ctr" indent="0" marL="0">
-              <a:buNone/>
-            </a:pPr>
-            <a:r>
-              <a:rPr lang="en-US" sz="1500" dirty="0">
-                <a:solidFill>
-                  <a:srgbClr val="8B96C2"/>
-                </a:solidFill>
-                <a:latin typeface="Arial" pitchFamily="34" charset="0"/>
-                <a:ea typeface="Arial" pitchFamily="34" charset="-122"/>
-                <a:cs typeface="Arial" pitchFamily="34" charset="-120"/>
-              </a:rPr>
-              <a:t>  for the live city  ·  </a:t>
-            </a:r>
-            <a:pPr algn="ctr" indent="0" marL="0">
-              <a:buNone/>
-            </a:pPr>
-            <a:r>
-              <a:rPr lang="en-US" sz="1500" b="1" dirty="0">
-                <a:solidFill>
-                  <a:srgbClr val="DFE6FF"/>
-                </a:solidFill>
-                <a:latin typeface="Arial" pitchFamily="34" charset="0"/>
-                <a:ea typeface="Arial" pitchFamily="34" charset="-122"/>
-                <a:cs typeface="Arial" pitchFamily="34" charset="-120"/>
-              </a:rPr>
-              <a:t>Gemini on Vertex</a:t>
-            </a:r>
-            <a:pPr algn="ctr" indent="0" marL="0">
-              <a:buNone/>
-            </a:pPr>
-            <a:r>
-              <a:rPr lang="en-US" sz="1500" dirty="0">
-                <a:solidFill>
-                  <a:srgbClr val="8B96C2"/>
-                </a:solidFill>
-                <a:latin typeface="Arial" pitchFamily="34" charset="0"/>
-                <a:ea typeface="Arial" pitchFamily="34" charset="-122"/>
-                <a:cs typeface="Arial" pitchFamily="34" charset="-120"/>
-              </a:rPr>
-              <a:t>  in the ring</a:t>
-            </a:r>
-            <a:endParaRPr lang="en-US" sz="1500" dirty="0"/>
-          </a:p>
-        </p:txBody>
-      </p:sp>
-      <p:sp>
-        <p:nvSpPr>
-          <p:cNvPr id="19" name="Text 17"/>
-          <p:cNvSpPr txBox="1"/>
-          <p:nvPr/>
-        </p:nvSpPr>
-        <p:spPr>
-          <a:xfrm>
-            <a:off x="640080" y="5577840"/>
-            <a:ext cx="10972800" cy="457200"/>
-          </a:xfrm>
-          <a:prstGeom prst="rect">
-            <a:avLst/>
-          </a:prstGeom>
-          <a:noFill/>
-          <a:ln/>
-        </p:spPr>
-        <p:txBody>
-          <a:bodyPr wrap="square" lIns="0" tIns="0" rIns="0" bIns="0" rtlCol="0" anchor="ctr"/>
-          <a:lstStyle/>
-          <a:p>
-            <a:pPr algn="ctr" indent="0" marL="0">
-              <a:buNone/>
-            </a:pPr>
-            <a:r>
-              <a:rPr lang="en-US" sz="1500" i="1" dirty="0">
-                <a:solidFill>
-                  <a:srgbClr val="FFB347"/>
                 </a:solidFill>
                 <a:latin typeface="Cambria" pitchFamily="34" charset="0"/>
                 <a:ea typeface="Cambria" pitchFamily="34" charset="-122"/>
                 <a:cs typeface="Cambria" pitchFamily="34" charset="-120"/>
               </a:rPr>
-              <a:t>The frontend holds zero fight logic — ten JSON events drive everything you see.</a:t>
-            </a:r>
-            <a:endParaRPr lang="en-US" sz="1500" dirty="0"/>
+              <a:t>git push · gh pr create</a:t>
+            </a:r>
+            <a:endParaRPr lang="en-US" sz="1050" dirty="0"/>
+          </a:p>
+        </p:txBody>
+      </p:sp>
+      <p:sp>
+        <p:nvSpPr>
+          <p:cNvPr id="40" name="Shape 38"/>
+          <p:cNvSpPr/>
+          <p:nvPr/>
+        </p:nvSpPr>
+        <p:spPr>
+          <a:xfrm flipH="1">
+            <a:off x="9418320" y="3200400"/>
+            <a:ext cx="-1828800" cy="-1097280"/>
+          </a:xfrm>
+          <a:prstGeom prst="line">
+            <a:avLst/>
+          </a:prstGeom>
+          <a:noFill/>
+          <a:ln w="19050">
+            <a:solidFill>
+              <a:srgbClr val="8B96C2"/>
+            </a:solidFill>
+            <a:prstDash val="solid"/>
+            <a:tailEnd type="triangle"/>
+          </a:ln>
+        </p:spPr>
+      </p:sp>
+      <p:sp>
+        <p:nvSpPr>
+          <p:cNvPr id="41" name="Shape 39"/>
+          <p:cNvSpPr/>
+          <p:nvPr/>
+        </p:nvSpPr>
+        <p:spPr>
+          <a:xfrm>
+            <a:off x="7589520" y="3017520"/>
+            <a:ext cx="1828800" cy="1828800"/>
+          </a:xfrm>
+          <a:prstGeom prst="line">
+            <a:avLst/>
+          </a:prstGeom>
+          <a:noFill/>
+          <a:ln w="19050">
+            <a:solidFill>
+              <a:srgbClr val="8B96C2"/>
+            </a:solidFill>
+            <a:prstDash val="solid"/>
+            <a:tailEnd type="triangle"/>
+          </a:ln>
+        </p:spPr>
+      </p:sp>
+      <p:sp>
+        <p:nvSpPr>
+          <p:cNvPr id="42" name="Text 40"/>
+          <p:cNvSpPr txBox="1"/>
+          <p:nvPr/>
+        </p:nvSpPr>
+        <p:spPr>
+          <a:xfrm>
+            <a:off x="8549640" y="3977640"/>
+            <a:ext cx="914400" cy="320040"/>
+          </a:xfrm>
+          <a:prstGeom prst="rect">
+            <a:avLst/>
+          </a:prstGeom>
+          <a:noFill/>
+          <a:ln/>
+        </p:spPr>
+        <p:txBody>
+          <a:bodyPr wrap="square" lIns="0" tIns="0" rIns="0" bIns="0" rtlCol="0" anchor="ctr"/>
+          <a:lstStyle/>
+          <a:p>
+            <a:pPr algn="ctr" indent="0" marL="0">
+              <a:buNone/>
+            </a:pPr>
+            <a:r>
+              <a:rPr lang="en-US" sz="1050" i="1" dirty="0">
+                <a:solidFill>
+                  <a:srgbClr val="8B96C2"/>
+                </a:solidFill>
+                <a:latin typeface="Cambria" pitchFamily="34" charset="0"/>
+                <a:ea typeface="Cambria" pitchFamily="34" charset="-122"/>
+                <a:cs typeface="Cambria" pitchFamily="34" charset="-120"/>
+              </a:rPr>
+              <a:t>events</a:t>
+            </a:r>
+            <a:endParaRPr lang="en-US" sz="1050" dirty="0"/>
+          </a:p>
+        </p:txBody>
+      </p:sp>
+      <p:sp>
+        <p:nvSpPr>
+          <p:cNvPr id="43" name="Text 41"/>
+          <p:cNvSpPr txBox="1"/>
+          <p:nvPr/>
+        </p:nvSpPr>
+        <p:spPr>
+          <a:xfrm>
+            <a:off x="548640" y="6446520"/>
+            <a:ext cx="8595360" cy="365760"/>
+          </a:xfrm>
+          <a:prstGeom prst="rect">
+            <a:avLst/>
+          </a:prstGeom>
+          <a:noFill/>
+          <a:ln/>
+        </p:spPr>
+        <p:txBody>
+          <a:bodyPr wrap="square" lIns="0" tIns="0" rIns="0" bIns="0" rtlCol="0" anchor="ctr"/>
+          <a:lstStyle/>
+          <a:p>
+            <a:pPr indent="0" marL="0">
+              <a:buNone/>
+            </a:pPr>
+            <a:r>
+              <a:rPr lang="en-US" sz="1250" i="1" dirty="0">
+                <a:solidFill>
+                  <a:srgbClr val="FFB347"/>
+                </a:solidFill>
+                <a:latin typeface="Cambria" pitchFamily="34" charset="0"/>
+                <a:ea typeface="Cambria" pitchFamily="34" charset="-122"/>
+                <a:cs typeface="Cambria" pitchFamily="34" charset="-120"/>
+              </a:rPr>
+              <a:t>60% original tests · 25% review findings · 15% diff economy  →  one verdict, shown live</a:t>
+            </a:r>
+            <a:endParaRPr lang="en-US" sz="1250" dirty="0"/>
           </a:p>
         </p:txBody>
       </p:sp>

</xml_diff>

<commit_message>
docs: chip architecture back, fuller Why slide
Co-Authored-By: Claude Fable 5 <noreply@anthropic.com>
</commit_message>
<xml_diff>
--- a/docs/deck/agent-fight-city.pptx
+++ b/docs/deck/agent-fight-city.pptx
@@ -1434,8 +1434,8 @@
         </p:blipFill>
         <p:spPr>
           <a:xfrm>
-            <a:off x="6766560" y="0"/>
-            <a:ext cx="5422392" cy="6858000"/>
+            <a:off x="7406640" y="0"/>
+            <a:ext cx="4782312" cy="6858000"/>
           </a:xfrm>
           <a:prstGeom prst="rect">
             <a:avLst/>
@@ -1450,8 +1450,8 @@
         </p:nvSpPr>
         <p:spPr>
           <a:xfrm>
-            <a:off x="640080" y="914400"/>
-            <a:ext cx="5760720" cy="1645920"/>
+            <a:off x="640080" y="502920"/>
+            <a:ext cx="6400800" cy="731520"/>
           </a:xfrm>
           <a:prstGeom prst="rect">
             <a:avLst/>
@@ -1467,7 +1467,7 @@
               <a:buNone/>
             </a:pPr>
             <a:r>
-              <a:rPr lang="en-US" sz="4000" b="1" dirty="0">
+              <a:rPr lang="en-US" sz="3600" b="1" dirty="0">
                 <a:solidFill>
                   <a:srgbClr val="DFE6FF"/>
                 </a:solidFill>
@@ -1475,16 +1475,38 @@
                 <a:ea typeface="Arial" pitchFamily="34" charset="-122"/>
                 <a:cs typeface="Arial" pitchFamily="34" charset="-120"/>
               </a:rPr>
-              <a:t>Benchmarks rank</a:t>
-            </a:r>
-            <a:endParaRPr lang="en-US" sz="4000" dirty="0"/>
-          </a:p>
+              <a:t>Why we built this</a:t>
+            </a:r>
+            <a:endParaRPr lang="en-US" sz="3600" dirty="0"/>
+          </a:p>
+        </p:txBody>
+      </p:sp>
+      <p:sp>
+        <p:nvSpPr>
+          <p:cNvPr id="4" name="Text 1"/>
+          <p:cNvSpPr txBox="1"/>
+          <p:nvPr/>
+        </p:nvSpPr>
+        <p:spPr>
+          <a:xfrm>
+            <a:off x="640080" y="1554480"/>
+            <a:ext cx="6400800" cy="1097280"/>
+          </a:xfrm>
+          <a:prstGeom prst="rect">
+            <a:avLst/>
+          </a:prstGeom>
+          <a:noFill/>
+          <a:ln/>
+        </p:spPr>
+        <p:txBody>
+          <a:bodyPr wrap="square" lIns="0" tIns="0" rIns="0" bIns="0" rtlCol="0" anchor="ctr"/>
+          <a:lstStyle/>
           <a:p>
             <a:pPr indent="0" marL="0">
               <a:buNone/>
             </a:pPr>
             <a:r>
-              <a:rPr lang="en-US" sz="4000" b="1" dirty="0">
+              <a:rPr lang="en-US" sz="1700" dirty="0">
                 <a:solidFill>
                   <a:srgbClr val="DFE6FF"/>
                 </a:solidFill>
@@ -1492,22 +1514,22 @@
                 <a:ea typeface="Arial" pitchFamily="34" charset="-122"/>
                 <a:cs typeface="Arial" pitchFamily="34" charset="-120"/>
               </a:rPr>
-              <a:t>averages.</a:t>
-            </a:r>
-            <a:endParaRPr lang="en-US" sz="4000" dirty="0"/>
-          </a:p>
-        </p:txBody>
-      </p:sp>
-      <p:sp>
-        <p:nvSpPr>
-          <p:cNvPr id="4" name="Text 1"/>
+              <a:t>A leaderboard says one model scores 71% and another 73%. That number tells you nothing about your Tuesday night bug, in your codebase, with your weird test setup.</a:t>
+            </a:r>
+            <a:endParaRPr lang="en-US" sz="1700" dirty="0"/>
+          </a:p>
+        </p:txBody>
+      </p:sp>
+      <p:sp>
+        <p:nvSpPr>
+          <p:cNvPr id="5" name="Text 2"/>
           <p:cNvSpPr txBox="1"/>
           <p:nvPr/>
         </p:nvSpPr>
         <p:spPr>
           <a:xfrm>
-            <a:off x="640080" y="2651760"/>
-            <a:ext cx="5760720" cy="640080"/>
+            <a:off x="640080" y="2788920"/>
+            <a:ext cx="6400800" cy="914400"/>
           </a:xfrm>
           <a:prstGeom prst="rect">
             <a:avLst/>
@@ -1523,30 +1545,30 @@
               <a:buNone/>
             </a:pPr>
             <a:r>
-              <a:rPr lang="en-US" sz="2600" dirty="0">
-                <a:solidFill>
-                  <a:srgbClr val="8B96C2"/>
+              <a:rPr lang="en-US" sz="1700" dirty="0">
+                <a:solidFill>
+                  <a:srgbClr val="DFE6FF"/>
                 </a:solidFill>
                 <a:latin typeface="Arial" pitchFamily="34" charset="0"/>
                 <a:ea typeface="Arial" pitchFamily="34" charset="-122"/>
                 <a:cs typeface="Arial" pitchFamily="34" charset="-120"/>
               </a:rPr>
-              <a:t>Nobody ships averages.</a:t>
-            </a:r>
-            <a:endParaRPr lang="en-US" sz="2600" dirty="0"/>
-          </a:p>
-        </p:txBody>
-      </p:sp>
-      <p:sp>
-        <p:nvSpPr>
-          <p:cNvPr id="5" name="Text 2"/>
+              <a:t>The only benchmark that matters looks like your actual job: a real repo, a real open issue, and a test suite that must not break.</a:t>
+            </a:r>
+            <a:endParaRPr lang="en-US" sz="1700" dirty="0"/>
+          </a:p>
+        </p:txBody>
+      </p:sp>
+      <p:sp>
+        <p:nvSpPr>
+          <p:cNvPr id="6" name="Text 3"/>
           <p:cNvSpPr txBox="1"/>
           <p:nvPr/>
         </p:nvSpPr>
         <p:spPr>
           <a:xfrm>
-            <a:off x="640080" y="3657600"/>
-            <a:ext cx="5760720" cy="1188720"/>
+            <a:off x="640080" y="3931920"/>
+            <a:ext cx="6400800" cy="1280160"/>
           </a:xfrm>
           <a:prstGeom prst="rect">
             <a:avLst/>
@@ -1562,7 +1584,46 @@
               <a:buNone/>
             </a:pPr>
             <a:r>
-              <a:rPr lang="en-US" sz="2200" i="1" dirty="0">
+              <a:rPr lang="en-US" sz="1700" dirty="0">
+                <a:solidFill>
+                  <a:srgbClr val="DFE6FF"/>
+                </a:solidFill>
+                <a:latin typeface="Arial" pitchFamily="34" charset="0"/>
+                <a:ea typeface="Arial" pitchFamily="34" charset="-122"/>
+                <a:cs typeface="Arial" pitchFamily="34" charset="-120"/>
+              </a:rPr>
+              <a:t>So every fight here is exactly that. Two agents get the same bug in separate sandboxed clones. Nobody grades their own homework: the referee judges only on the original tests from main, an honest code review, and how small the diff is.</a:t>
+            </a:r>
+            <a:endParaRPr lang="en-US" sz="1700" dirty="0"/>
+          </a:p>
+        </p:txBody>
+      </p:sp>
+      <p:sp>
+        <p:nvSpPr>
+          <p:cNvPr id="7" name="Text 4"/>
+          <p:cNvSpPr txBox="1"/>
+          <p:nvPr/>
+        </p:nvSpPr>
+        <p:spPr>
+          <a:xfrm>
+            <a:off x="640080" y="5486400"/>
+            <a:ext cx="6400800" cy="822960"/>
+          </a:xfrm>
+          <a:prstGeom prst="rect">
+            <a:avLst/>
+          </a:prstGeom>
+          <a:noFill/>
+          <a:ln/>
+        </p:spPr>
+        <p:txBody>
+          <a:bodyPr wrap="square" lIns="0" tIns="0" rIns="0" bIns="0" rtlCol="0" anchor="ctr"/>
+          <a:lstStyle/>
+          <a:p>
+            <a:pPr indent="0" marL="0">
+              <a:buNone/>
+            </a:pPr>
+            <a:r>
+              <a:rPr lang="en-US" sz="1900" i="1" dirty="0">
                 <a:solidFill>
                   <a:srgbClr val="FFB347"/>
                 </a:solidFill>
@@ -1570,65 +1631,9 @@
                 <a:ea typeface="Cambria" pitchFamily="34" charset="-122"/>
                 <a:cs typeface="Cambria" pitchFamily="34" charset="-120"/>
               </a:rPr>
-              <a:t>Which agent fixes THIS bug,</a:t>
-            </a:r>
-            <a:endParaRPr lang="en-US" sz="2200" dirty="0"/>
-          </a:p>
-          <a:p>
-            <a:pPr indent="0" marL="0">
-              <a:buNone/>
-            </a:pPr>
-            <a:r>
-              <a:rPr lang="en-US" sz="2200" i="1" dirty="0">
-                <a:solidFill>
-                  <a:srgbClr val="FFB347"/>
-                </a:solidFill>
-                <a:latin typeface="Cambria" pitchFamily="34" charset="0"/>
-                <a:ea typeface="Cambria" pitchFamily="34" charset="-122"/>
-                <a:cs typeface="Cambria" pitchFamily="34" charset="-120"/>
-              </a:rPr>
-              <a:t>in MY repo, without breaking anything?</a:t>
-            </a:r>
-            <a:endParaRPr lang="en-US" sz="2200" dirty="0"/>
-          </a:p>
-        </p:txBody>
-      </p:sp>
-      <p:sp>
-        <p:nvSpPr>
-          <p:cNvPr id="6" name="Text 3"/>
-          <p:cNvSpPr txBox="1"/>
-          <p:nvPr/>
-        </p:nvSpPr>
-        <p:spPr>
-          <a:xfrm>
-            <a:off x="640080" y="5212080"/>
-            <a:ext cx="5760720" cy="640080"/>
-          </a:xfrm>
-          <a:prstGeom prst="rect">
-            <a:avLst/>
-          </a:prstGeom>
-          <a:noFill/>
-          <a:ln/>
-        </p:spPr>
-        <p:txBody>
-          <a:bodyPr wrap="square" lIns="0" tIns="0" rIns="0" bIns="0" rtlCol="0" anchor="ctr"/>
-          <a:lstStyle/>
-          <a:p>
-            <a:pPr indent="0" marL="0">
-              <a:buNone/>
-            </a:pPr>
-            <a:r>
-              <a:rPr lang="en-US" sz="2600" b="1" dirty="0">
-                <a:solidFill>
-                  <a:srgbClr val="6FE3A1"/>
-                </a:solidFill>
-                <a:latin typeface="Arial" pitchFamily="34" charset="0"/>
-                <a:ea typeface="Arial" pitchFamily="34" charset="-122"/>
-                <a:cs typeface="Arial" pitchFamily="34" charset="-120"/>
-              </a:rPr>
-              <a:t>So we made them fight.</a:t>
-            </a:r>
-            <a:endParaRPr lang="en-US" sz="2600" dirty="0"/>
+              <a:t>And since watching agents work is usually a spinner, we made it a city instead.</a:t>
+            </a:r>
+            <a:endParaRPr lang="en-US" sz="1900" dirty="0"/>
           </a:p>
         </p:txBody>
       </p:sp>
@@ -1908,8 +1913,8 @@
         </p:nvSpPr>
         <p:spPr>
           <a:xfrm>
-            <a:off x="548640" y="228600"/>
-            <a:ext cx="10972800" cy="548640"/>
+            <a:off x="640080" y="365760"/>
+            <a:ext cx="10972800" cy="640080"/>
           </a:xfrm>
           <a:prstGeom prst="rect">
             <a:avLst/>
@@ -1925,7 +1930,7 @@
               <a:buNone/>
             </a:pPr>
             <a:r>
-              <a:rPr lang="en-US" sz="3000" b="1" dirty="0">
+              <a:rPr lang="en-US" sz="3200" b="1" dirty="0">
                 <a:solidFill>
                   <a:srgbClr val="DFE6FF"/>
                 </a:solidFill>
@@ -1933,9 +1938,9 @@
                 <a:ea typeface="Arial" pitchFamily="34" charset="-122"/>
                 <a:cs typeface="Arial" pitchFamily="34" charset="-120"/>
               </a:rPr>
-              <a:t>Architecture</a:t>
-            </a:r>
-            <a:endParaRPr lang="en-US" sz="3000" dirty="0"/>
+              <a:t>How a fight flows</a:t>
+            </a:r>
+            <a:endParaRPr lang="en-US" sz="3200" dirty="0"/>
           </a:p>
         </p:txBody>
       </p:sp>
@@ -1947,18 +1952,18 @@
         </p:nvSpPr>
         <p:spPr>
           <a:xfrm>
-            <a:off x="548640" y="1005840"/>
-            <a:ext cx="2743200" cy="2286000"/>
+            <a:off x="640080" y="1828800"/>
+            <a:ext cx="2514600" cy="2286000"/>
           </a:xfrm>
           <a:prstGeom prst="roundRect">
             <a:avLst>
-              <a:gd name="adj" fmla="val 3200"/>
+              <a:gd name="adj" fmla="val 4800"/>
             </a:avLst>
           </a:prstGeom>
           <a:solidFill>
             <a:srgbClr val="141A2E"/>
           </a:solidFill>
-          <a:ln w="15875">
+          <a:ln w="19050">
             <a:solidFill>
               <a:srgbClr val="7EC8FF"/>
             </a:solidFill>
@@ -1974,8 +1979,8 @@
         </p:nvSpPr>
         <p:spPr>
           <a:xfrm>
-            <a:off x="685800" y="1143000"/>
-            <a:ext cx="2468880" cy="320040"/>
+            <a:off x="777240" y="2148840"/>
+            <a:ext cx="2240280" cy="548640"/>
           </a:xfrm>
           <a:prstGeom prst="rect">
             <a:avLst/>
@@ -1991,7 +1996,7 @@
               <a:buNone/>
             </a:pPr>
             <a:r>
-              <a:rPr lang="en-US" sz="1500" b="1" dirty="0">
+              <a:rPr lang="en-US" sz="2100" b="1" dirty="0">
                 <a:solidFill>
                   <a:srgbClr val="7EC8FF"/>
                 </a:solidFill>
@@ -1999,9 +2004,9 @@
                 <a:ea typeface="Arial" pitchFamily="34" charset="-122"/>
                 <a:cs typeface="Arial" pitchFamily="34" charset="-120"/>
               </a:rPr>
-              <a:t>BROWSER</a:t>
-            </a:r>
-            <a:endParaRPr lang="en-US" sz="1500" dirty="0"/>
+              <a:t>Bright Data</a:t>
+            </a:r>
+            <a:endParaRPr lang="en-US" sz="2100" dirty="0"/>
           </a:p>
         </p:txBody>
       </p:sp>
@@ -2013,8 +2018,8 @@
         </p:nvSpPr>
         <p:spPr>
           <a:xfrm>
-            <a:off x="685800" y="1600200"/>
-            <a:ext cx="2468880" cy="1463040"/>
+            <a:off x="777240" y="2788920"/>
+            <a:ext cx="2240280" cy="1097280"/>
           </a:xfrm>
           <a:prstGeom prst="rect">
             <a:avLst/>
@@ -2030,7 +2035,7 @@
               <a:buNone/>
             </a:pPr>
             <a:r>
-              <a:rPr lang="en-US" sz="1250" dirty="0">
+              <a:rPr lang="en-US" sz="1350" dirty="0">
                 <a:solidFill>
                   <a:srgbClr val="DFE6FF"/>
                 </a:solidFill>
@@ -2038,16 +2043,16 @@
                 <a:ea typeface="Arial" pitchFamily="34" charset="-122"/>
                 <a:cs typeface="Arial" pitchFamily="34" charset="-120"/>
               </a:rPr>
-              <a:t>Three.js city + HUD</a:t>
-            </a:r>
-            <a:endParaRPr lang="en-US" sz="1250" dirty="0"/>
+              <a:t>scrapes live GitHub —</a:t>
+            </a:r>
+            <a:endParaRPr lang="en-US" sz="1350" dirty="0"/>
           </a:p>
           <a:p>
             <a:pPr algn="ctr" indent="0" marL="0">
               <a:buNone/>
             </a:pPr>
             <a:r>
-              <a:rPr lang="en-US" sz="1250" dirty="0">
+              <a:rPr lang="en-US" sz="1350" dirty="0">
                 <a:solidFill>
                   <a:srgbClr val="DFE6FF"/>
                 </a:solidFill>
@@ -2055,66 +2060,393 @@
                 <a:ea typeface="Arial" pitchFamily="34" charset="-122"/>
                 <a:cs typeface="Arial" pitchFamily="34" charset="-120"/>
               </a:rPr>
-              <a:t>replay scrubber</a:t>
-            </a:r>
-            <a:endParaRPr lang="en-US" sz="1250" dirty="0"/>
-          </a:p>
+              <a:t>the skyline IS the data</a:t>
+            </a:r>
+            <a:endParaRPr lang="en-US" sz="1350" dirty="0"/>
+          </a:p>
+        </p:txBody>
+      </p:sp>
+      <p:sp>
+        <p:nvSpPr>
+          <p:cNvPr id="6" name="Text 4"/>
+          <p:cNvSpPr txBox="1"/>
+          <p:nvPr/>
+        </p:nvSpPr>
+        <p:spPr>
+          <a:xfrm>
+            <a:off x="3172968" y="2651760"/>
+            <a:ext cx="411480" cy="640080"/>
+          </a:xfrm>
+          <a:prstGeom prst="rect">
+            <a:avLst/>
+          </a:prstGeom>
+          <a:noFill/>
+          <a:ln/>
+        </p:spPr>
+        <p:txBody>
+          <a:bodyPr wrap="square" lIns="0" tIns="0" rIns="0" bIns="0" rtlCol="0" anchor="ctr"/>
+          <a:lstStyle/>
           <a:p>
             <a:pPr algn="ctr" indent="0" marL="0">
               <a:buNone/>
             </a:pPr>
             <a:r>
-              <a:rPr lang="en-US" sz="1250" dirty="0">
-                <a:solidFill>
-                  <a:srgbClr val="DFE6FF"/>
+              <a:rPr lang="en-US" sz="2600" b="1" dirty="0">
+                <a:solidFill>
+                  <a:srgbClr val="8B96C2"/>
                 </a:solidFill>
                 <a:latin typeface="Arial" pitchFamily="34" charset="0"/>
                 <a:ea typeface="Arial" pitchFamily="34" charset="-122"/>
                 <a:cs typeface="Arial" pitchFamily="34" charset="-120"/>
               </a:rPr>
-              <a:t>zero fight logic —</a:t>
-            </a:r>
-            <a:endParaRPr lang="en-US" sz="1250" dirty="0"/>
-          </a:p>
+              <a:t>→</a:t>
+            </a:r>
+            <a:endParaRPr lang="en-US" sz="2600" dirty="0"/>
+          </a:p>
+        </p:txBody>
+      </p:sp>
+      <p:sp>
+        <p:nvSpPr>
+          <p:cNvPr id="7" name="Shape 5"/>
+          <p:cNvSpPr/>
+          <p:nvPr/>
+        </p:nvSpPr>
+        <p:spPr>
+          <a:xfrm>
+            <a:off x="3566160" y="1828800"/>
+            <a:ext cx="2514600" cy="2286000"/>
+          </a:xfrm>
+          <a:prstGeom prst="roundRect">
+            <a:avLst>
+              <a:gd name="adj" fmla="val 4800"/>
+            </a:avLst>
+          </a:prstGeom>
+          <a:solidFill>
+            <a:srgbClr val="141A2E"/>
+          </a:solidFill>
+          <a:ln w="19050">
+            <a:solidFill>
+              <a:srgbClr val="FFB347"/>
+            </a:solidFill>
+            <a:prstDash val="solid"/>
+          </a:ln>
+        </p:spPr>
+      </p:sp>
+      <p:sp>
+        <p:nvSpPr>
+          <p:cNvPr id="8" name="Text 6"/>
+          <p:cNvSpPr txBox="1"/>
+          <p:nvPr/>
+        </p:nvSpPr>
+        <p:spPr>
+          <a:xfrm>
+            <a:off x="3703320" y="2148840"/>
+            <a:ext cx="2240280" cy="548640"/>
+          </a:xfrm>
+          <a:prstGeom prst="rect">
+            <a:avLst/>
+          </a:prstGeom>
+          <a:noFill/>
+          <a:ln/>
+        </p:spPr>
+        <p:txBody>
+          <a:bodyPr wrap="square" lIns="0" tIns="0" rIns="0" bIns="0" rtlCol="0" anchor="ctr"/>
+          <a:lstStyle/>
           <a:p>
             <a:pPr algn="ctr" indent="0" marL="0">
               <a:buNone/>
             </a:pPr>
             <a:r>
-              <a:rPr lang="en-US" sz="1250" dirty="0">
-                <a:solidFill>
-                  <a:srgbClr val="DFE6FF"/>
+              <a:rPr lang="en-US" sz="2100" b="1" dirty="0">
+                <a:solidFill>
+                  <a:srgbClr val="FFB347"/>
                 </a:solidFill>
                 <a:latin typeface="Arial" pitchFamily="34" charset="0"/>
                 <a:ea typeface="Arial" pitchFamily="34" charset="-122"/>
                 <a:cs typeface="Arial" pitchFamily="34" charset="-120"/>
               </a:rPr>
-              <a:t>renders 10 event types</a:t>
-            </a:r>
-            <a:endParaRPr lang="en-US" sz="1250" dirty="0"/>
-          </a:p>
-        </p:txBody>
-      </p:sp>
-      <p:sp>
-        <p:nvSpPr>
-          <p:cNvPr id="6" name="Shape 4"/>
+              <a:t>TrueFoundry</a:t>
+            </a:r>
+            <a:endParaRPr lang="en-US" sz="2100" dirty="0"/>
+          </a:p>
+        </p:txBody>
+      </p:sp>
+      <p:sp>
+        <p:nvSpPr>
+          <p:cNvPr id="9" name="Text 7"/>
+          <p:cNvSpPr txBox="1"/>
+          <p:nvPr/>
+        </p:nvSpPr>
+        <p:spPr>
+          <a:xfrm>
+            <a:off x="3703320" y="2788920"/>
+            <a:ext cx="2240280" cy="1097280"/>
+          </a:xfrm>
+          <a:prstGeom prst="rect">
+            <a:avLst/>
+          </a:prstGeom>
+          <a:noFill/>
+          <a:ln/>
+        </p:spPr>
+        <p:txBody>
+          <a:bodyPr wrap="square" lIns="0" tIns="0" rIns="0" bIns="0" rtlCol="0" anchor="ctr"/>
+          <a:lstStyle/>
+          <a:p>
+            <a:pPr algn="ctr" indent="0" marL="0">
+              <a:buNone/>
+            </a:pPr>
+            <a:r>
+              <a:rPr lang="en-US" sz="1350" dirty="0">
+                <a:solidFill>
+                  <a:srgbClr val="DFE6FF"/>
+                </a:solidFill>
+                <a:latin typeface="Arial" pitchFamily="34" charset="0"/>
+                <a:ea typeface="Arial" pitchFamily="34" charset="-122"/>
+                <a:cs typeface="Arial" pitchFamily="34" charset="-120"/>
+              </a:rPr>
+              <a:t>AI gateway runs the</a:t>
+            </a:r>
+            <a:endParaRPr lang="en-US" sz="1350" dirty="0"/>
+          </a:p>
+          <a:p>
+            <a:pPr algn="ctr" indent="0" marL="0">
+              <a:buNone/>
+            </a:pPr>
+            <a:r>
+              <a:rPr lang="en-US" sz="1350" dirty="0">
+                <a:solidFill>
+                  <a:srgbClr val="DFE6FF"/>
+                </a:solidFill>
+                <a:latin typeface="Arial" pitchFamily="34" charset="0"/>
+                <a:ea typeface="Arial" pitchFamily="34" charset="-122"/>
+                <a:cs typeface="Arial" pitchFamily="34" charset="-120"/>
+              </a:rPr>
+              <a:t>fighter + referee agents</a:t>
+            </a:r>
+            <a:endParaRPr lang="en-US" sz="1350" dirty="0"/>
+          </a:p>
+        </p:txBody>
+      </p:sp>
+      <p:sp>
+        <p:nvSpPr>
+          <p:cNvPr id="10" name="Text 8"/>
+          <p:cNvSpPr txBox="1"/>
+          <p:nvPr/>
+        </p:nvSpPr>
+        <p:spPr>
+          <a:xfrm>
+            <a:off x="6099048" y="2651760"/>
+            <a:ext cx="411480" cy="640080"/>
+          </a:xfrm>
+          <a:prstGeom prst="rect">
+            <a:avLst/>
+          </a:prstGeom>
+          <a:noFill/>
+          <a:ln/>
+        </p:spPr>
+        <p:txBody>
+          <a:bodyPr wrap="square" lIns="0" tIns="0" rIns="0" bIns="0" rtlCol="0" anchor="ctr"/>
+          <a:lstStyle/>
+          <a:p>
+            <a:pPr algn="ctr" indent="0" marL="0">
+              <a:buNone/>
+            </a:pPr>
+            <a:r>
+              <a:rPr lang="en-US" sz="2600" b="1" dirty="0">
+                <a:solidFill>
+                  <a:srgbClr val="8B96C2"/>
+                </a:solidFill>
+                <a:latin typeface="Arial" pitchFamily="34" charset="0"/>
+                <a:ea typeface="Arial" pitchFamily="34" charset="-122"/>
+                <a:cs typeface="Arial" pitchFamily="34" charset="-120"/>
+              </a:rPr>
+              <a:t>→</a:t>
+            </a:r>
+            <a:endParaRPr lang="en-US" sz="2600" dirty="0"/>
+          </a:p>
+        </p:txBody>
+      </p:sp>
+      <p:sp>
+        <p:nvSpPr>
+          <p:cNvPr id="11" name="Shape 9"/>
           <p:cNvSpPr/>
           <p:nvPr/>
         </p:nvSpPr>
         <p:spPr>
           <a:xfrm>
-            <a:off x="4480560" y="1005840"/>
-            <a:ext cx="3108960" cy="2286000"/>
+            <a:off x="6492240" y="1828800"/>
+            <a:ext cx="2514600" cy="2286000"/>
           </a:xfrm>
           <a:prstGeom prst="roundRect">
             <a:avLst>
-              <a:gd name="adj" fmla="val 3200"/>
+              <a:gd name="adj" fmla="val 4800"/>
             </a:avLst>
           </a:prstGeom>
           <a:solidFill>
             <a:srgbClr val="141A2E"/>
           </a:solidFill>
-          <a:ln w="15875">
+          <a:ln w="19050">
+            <a:solidFill>
+              <a:srgbClr val="C9A5FF"/>
+            </a:solidFill>
+            <a:prstDash val="solid"/>
+          </a:ln>
+        </p:spPr>
+      </p:sp>
+      <p:sp>
+        <p:nvSpPr>
+          <p:cNvPr id="12" name="Text 10"/>
+          <p:cNvSpPr txBox="1"/>
+          <p:nvPr/>
+        </p:nvSpPr>
+        <p:spPr>
+          <a:xfrm>
+            <a:off x="6629400" y="2148840"/>
+            <a:ext cx="2240280" cy="548640"/>
+          </a:xfrm>
+          <a:prstGeom prst="rect">
+            <a:avLst/>
+          </a:prstGeom>
+          <a:noFill/>
+          <a:ln/>
+        </p:spPr>
+        <p:txBody>
+          <a:bodyPr wrap="square" lIns="0" tIns="0" rIns="0" bIns="0" rtlCol="0" anchor="ctr"/>
+          <a:lstStyle/>
+          <a:p>
+            <a:pPr algn="ctr" indent="0" marL="0">
+              <a:buNone/>
+            </a:pPr>
+            <a:r>
+              <a:rPr lang="en-US" sz="2100" b="1" dirty="0">
+                <a:solidFill>
+                  <a:srgbClr val="C9A5FF"/>
+                </a:solidFill>
+                <a:latin typeface="Arial" pitchFamily="34" charset="0"/>
+                <a:ea typeface="Arial" pitchFamily="34" charset="-122"/>
+                <a:cs typeface="Arial" pitchFamily="34" charset="-120"/>
+              </a:rPr>
+              <a:t>Qodo</a:t>
+            </a:r>
+            <a:endParaRPr lang="en-US" sz="2100" dirty="0"/>
+          </a:p>
+        </p:txBody>
+      </p:sp>
+      <p:sp>
+        <p:nvSpPr>
+          <p:cNvPr id="13" name="Text 11"/>
+          <p:cNvSpPr txBox="1"/>
+          <p:nvPr/>
+        </p:nvSpPr>
+        <p:spPr>
+          <a:xfrm>
+            <a:off x="6629400" y="2788920"/>
+            <a:ext cx="2240280" cy="1097280"/>
+          </a:xfrm>
+          <a:prstGeom prst="rect">
+            <a:avLst/>
+          </a:prstGeom>
+          <a:noFill/>
+          <a:ln/>
+        </p:spPr>
+        <p:txBody>
+          <a:bodyPr wrap="square" lIns="0" tIns="0" rIns="0" bIns="0" rtlCol="0" anchor="ctr"/>
+          <a:lstStyle/>
+          <a:p>
+            <a:pPr algn="ctr" indent="0" marL="0">
+              <a:buNone/>
+            </a:pPr>
+            <a:r>
+              <a:rPr lang="en-US" sz="1350" dirty="0">
+                <a:solidFill>
+                  <a:srgbClr val="DFE6FF"/>
+                </a:solidFill>
+                <a:latin typeface="Arial" pitchFamily="34" charset="0"/>
+                <a:ea typeface="Arial" pitchFamily="34" charset="-122"/>
+                <a:cs typeface="Arial" pitchFamily="34" charset="-120"/>
+              </a:rPr>
+              <a:t>review gates every PR —</a:t>
+            </a:r>
+            <a:endParaRPr lang="en-US" sz="1350" dirty="0"/>
+          </a:p>
+          <a:p>
+            <a:pPr algn="ctr" indent="0" marL="0">
+              <a:buNone/>
+            </a:pPr>
+            <a:r>
+              <a:rPr lang="en-US" sz="1350" dirty="0">
+                <a:solidFill>
+                  <a:srgbClr val="DFE6FF"/>
+                </a:solidFill>
+                <a:latin typeface="Arial" pitchFamily="34" charset="0"/>
+                <a:ea typeface="Arial" pitchFamily="34" charset="-122"/>
+                <a:cs typeface="Arial" pitchFamily="34" charset="-120"/>
+              </a:rPr>
+              <a:t>ours and the referee’s</a:t>
+            </a:r>
+            <a:endParaRPr lang="en-US" sz="1350" dirty="0"/>
+          </a:p>
+        </p:txBody>
+      </p:sp>
+      <p:sp>
+        <p:nvSpPr>
+          <p:cNvPr id="14" name="Text 12"/>
+          <p:cNvSpPr txBox="1"/>
+          <p:nvPr/>
+        </p:nvSpPr>
+        <p:spPr>
+          <a:xfrm>
+            <a:off x="9025128" y="2651760"/>
+            <a:ext cx="411480" cy="640080"/>
+          </a:xfrm>
+          <a:prstGeom prst="rect">
+            <a:avLst/>
+          </a:prstGeom>
+          <a:noFill/>
+          <a:ln/>
+        </p:spPr>
+        <p:txBody>
+          <a:bodyPr wrap="square" lIns="0" tIns="0" rIns="0" bIns="0" rtlCol="0" anchor="ctr"/>
+          <a:lstStyle/>
+          <a:p>
+            <a:pPr algn="ctr" indent="0" marL="0">
+              <a:buNone/>
+            </a:pPr>
+            <a:r>
+              <a:rPr lang="en-US" sz="2600" b="1" dirty="0">
+                <a:solidFill>
+                  <a:srgbClr val="8B96C2"/>
+                </a:solidFill>
+                <a:latin typeface="Arial" pitchFamily="34" charset="0"/>
+                <a:ea typeface="Arial" pitchFamily="34" charset="-122"/>
+                <a:cs typeface="Arial" pitchFamily="34" charset="-120"/>
+              </a:rPr>
+              <a:t>→</a:t>
+            </a:r>
+            <a:endParaRPr lang="en-US" sz="2600" dirty="0"/>
+          </a:p>
+        </p:txBody>
+      </p:sp>
+      <p:sp>
+        <p:nvSpPr>
+          <p:cNvPr id="15" name="Shape 13"/>
+          <p:cNvSpPr/>
+          <p:nvPr/>
+        </p:nvSpPr>
+        <p:spPr>
+          <a:xfrm>
+            <a:off x="9418320" y="1828800"/>
+            <a:ext cx="2514600" cy="2286000"/>
+          </a:xfrm>
+          <a:prstGeom prst="roundRect">
+            <a:avLst>
+              <a:gd name="adj" fmla="val 4800"/>
+            </a:avLst>
+          </a:prstGeom>
+          <a:solidFill>
+            <a:srgbClr val="141A2E"/>
+          </a:solidFill>
+          <a:ln w="19050">
             <a:solidFill>
               <a:srgbClr val="6FE3A1"/>
             </a:solidFill>
@@ -2124,14 +2456,14 @@
       </p:sp>
       <p:sp>
         <p:nvSpPr>
-          <p:cNvPr id="7" name="Text 5"/>
+          <p:cNvPr id="16" name="Text 14"/>
           <p:cNvSpPr txBox="1"/>
           <p:nvPr/>
         </p:nvSpPr>
         <p:spPr>
           <a:xfrm>
-            <a:off x="4617720" y="1143000"/>
-            <a:ext cx="2834640" cy="320040"/>
+            <a:off x="9555480" y="2148840"/>
+            <a:ext cx="2240280" cy="548640"/>
           </a:xfrm>
           <a:prstGeom prst="rect">
             <a:avLst/>
@@ -2147,7 +2479,7 @@
               <a:buNone/>
             </a:pPr>
             <a:r>
-              <a:rPr lang="en-US" sz="1500" b="1" dirty="0">
+              <a:rPr lang="en-US" sz="2100" b="1" dirty="0">
                 <a:solidFill>
                   <a:srgbClr val="6FE3A1"/>
                 </a:solidFill>
@@ -2155,22 +2487,22 @@
                 <a:ea typeface="Arial" pitchFamily="34" charset="-122"/>
                 <a:cs typeface="Arial" pitchFamily="34" charset="-120"/>
               </a:rPr>
-              <a:t>FastAPI SERVER</a:t>
-            </a:r>
-            <a:endParaRPr lang="en-US" sz="1500" dirty="0"/>
-          </a:p>
-        </p:txBody>
-      </p:sp>
-      <p:sp>
-        <p:nvSpPr>
-          <p:cNvPr id="8" name="Text 6"/>
+              <a:t>GitHub</a:t>
+            </a:r>
+            <a:endParaRPr lang="en-US" sz="2100" dirty="0"/>
+          </a:p>
+        </p:txBody>
+      </p:sp>
+      <p:sp>
+        <p:nvSpPr>
+          <p:cNvPr id="17" name="Text 15"/>
           <p:cNvSpPr txBox="1"/>
           <p:nvPr/>
         </p:nvSpPr>
         <p:spPr>
           <a:xfrm>
-            <a:off x="4617720" y="1600200"/>
-            <a:ext cx="2834640" cy="1463040"/>
+            <a:off x="9555480" y="2788920"/>
+            <a:ext cx="2240280" cy="1097280"/>
           </a:xfrm>
           <a:prstGeom prst="rect">
             <a:avLst/>
@@ -2186,7 +2518,7 @@
               <a:buNone/>
             </a:pPr>
             <a:r>
-              <a:rPr lang="en-US" sz="1250" dirty="0">
+              <a:rPr lang="en-US" sz="1350" dirty="0">
                 <a:solidFill>
                   <a:srgbClr val="DFE6FF"/>
                 </a:solidFill>
@@ -2194,16 +2526,16 @@
                 <a:ea typeface="Arial" pitchFamily="34" charset="-122"/>
                 <a:cs typeface="Arial" pitchFamily="34" charset="-120"/>
               </a:rPr>
-              <a:t>POST /fight  →  session</a:t>
-            </a:r>
-            <a:endParaRPr lang="en-US" sz="1250" dirty="0"/>
+              <a:t>winner’s PR opens,</a:t>
+            </a:r>
+            <a:endParaRPr lang="en-US" sz="1350" dirty="0"/>
           </a:p>
           <a:p>
             <a:pPr algn="ctr" indent="0" marL="0">
               <a:buNone/>
             </a:pPr>
             <a:r>
-              <a:rPr lang="en-US" sz="1250" dirty="0">
+              <a:rPr lang="en-US" sz="1350" dirty="0">
                 <a:solidFill>
                   <a:srgbClr val="DFE6FF"/>
                 </a:solidFill>
@@ -2211,33 +2543,52 @@
                 <a:ea typeface="Arial" pitchFamily="34" charset="-122"/>
                 <a:cs typeface="Arial" pitchFamily="34" charset="-120"/>
               </a:rPr>
-              <a:t>GET /events  (SSE)</a:t>
-            </a:r>
-            <a:endParaRPr lang="en-US" sz="1250" dirty="0"/>
-          </a:p>
+              <a:t>loser’s branch deleted</a:t>
+            </a:r>
+            <a:endParaRPr lang="en-US" sz="1350" dirty="0"/>
+          </a:p>
+        </p:txBody>
+      </p:sp>
+      <p:sp>
+        <p:nvSpPr>
+          <p:cNvPr id="18" name="Text 16"/>
+          <p:cNvSpPr txBox="1"/>
+          <p:nvPr/>
+        </p:nvSpPr>
+        <p:spPr>
+          <a:xfrm>
+            <a:off x="640080" y="4846320"/>
+            <a:ext cx="10972800" cy="457200"/>
+          </a:xfrm>
+          <a:prstGeom prst="rect">
+            <a:avLst/>
+          </a:prstGeom>
+          <a:noFill/>
+          <a:ln/>
+        </p:spPr>
+        <p:txBody>
+          <a:bodyPr wrap="square" lIns="0" tIns="0" rIns="0" bIns="0" rtlCol="0" anchor="ctr"/>
+          <a:lstStyle/>
           <a:p>
             <a:pPr algn="ctr" indent="0" marL="0">
               <a:buNone/>
             </a:pPr>
             <a:r>
-              <a:rPr lang="en-US" sz="1250" dirty="0">
-                <a:solidFill>
-                  <a:srgbClr val="DFE6FF"/>
+              <a:rPr lang="en-US" sz="1500" dirty="0">
+                <a:solidFill>
+                  <a:srgbClr val="8B96C2"/>
                 </a:solidFill>
                 <a:latin typeface="Arial" pitchFamily="34" charset="0"/>
                 <a:ea typeface="Arial" pitchFamily="34" charset="-122"/>
                 <a:cs typeface="Arial" pitchFamily="34" charset="-120"/>
               </a:rPr>
-              <a:t>GET /repos · /stats</a:t>
-            </a:r>
-            <a:endParaRPr lang="en-US" sz="1250" dirty="0"/>
-          </a:p>
-          <a:p>
+              <a:t>plus  </a:t>
+            </a:r>
             <a:pPr algn="ctr" indent="0" marL="0">
               <a:buNone/>
             </a:pPr>
             <a:r>
-              <a:rPr lang="en-US" sz="1250" dirty="0">
+              <a:rPr lang="en-US" sz="1500" b="1" dirty="0">
                 <a:solidFill>
                   <a:srgbClr val="DFE6FF"/>
                 </a:solidFill>
@@ -2245,46 +2596,92 @@
                 <a:ea typeface="Arial" pitchFamily="34" charset="-122"/>
                 <a:cs typeface="Arial" pitchFamily="34" charset="-120"/>
               </a:rPr>
-              <a:t>"a dumb pipe, on purpose"</a:t>
-            </a:r>
-            <a:endParaRPr lang="en-US" sz="1250" dirty="0"/>
-          </a:p>
-        </p:txBody>
-      </p:sp>
-      <p:sp>
-        <p:nvSpPr>
-          <p:cNvPr id="9" name="Shape 7"/>
-          <p:cNvSpPr/>
-          <p:nvPr/>
-        </p:nvSpPr>
-        <p:spPr>
-          <a:xfrm>
-            <a:off x="3291840" y="1737360"/>
-            <a:ext cx="1188720" cy="0"/>
-          </a:xfrm>
-          <a:prstGeom prst="line">
-            <a:avLst/>
-          </a:prstGeom>
-          <a:noFill/>
-          <a:ln w="19050">
-            <a:solidFill>
-              <a:srgbClr val="8B96C2"/>
-            </a:solidFill>
-            <a:prstDash val="solid"/>
-            <a:tailEnd type="triangle"/>
-          </a:ln>
-        </p:spPr>
-      </p:sp>
-      <p:sp>
-        <p:nvSpPr>
-          <p:cNvPr id="10" name="Text 8"/>
+              <a:t>ClickHouse Cloud</a:t>
+            </a:r>
+            <a:pPr algn="ctr" indent="0" marL="0">
+              <a:buNone/>
+            </a:pPr>
+            <a:r>
+              <a:rPr lang="en-US" sz="1500" dirty="0">
+                <a:solidFill>
+                  <a:srgbClr val="8B96C2"/>
+                </a:solidFill>
+                <a:latin typeface="Arial" pitchFamily="34" charset="0"/>
+                <a:ea typeface="Arial" pitchFamily="34" charset="-122"/>
+                <a:cs typeface="Arial" pitchFamily="34" charset="-120"/>
+              </a:rPr>
+              <a:t>  for every fight event  ·  </a:t>
+            </a:r>
+            <a:pPr algn="ctr" indent="0" marL="0">
+              <a:buNone/>
+            </a:pPr>
+            <a:r>
+              <a:rPr lang="en-US" sz="1500" b="1" dirty="0">
+                <a:solidFill>
+                  <a:srgbClr val="DFE6FF"/>
+                </a:solidFill>
+                <a:latin typeface="Arial" pitchFamily="34" charset="0"/>
+                <a:ea typeface="Arial" pitchFamily="34" charset="-122"/>
+                <a:cs typeface="Arial" pitchFamily="34" charset="-120"/>
+              </a:rPr>
+              <a:t>Vercel</a:t>
+            </a:r>
+            <a:pPr algn="ctr" indent="0" marL="0">
+              <a:buNone/>
+            </a:pPr>
+            <a:r>
+              <a:rPr lang="en-US" sz="1500" dirty="0">
+                <a:solidFill>
+                  <a:srgbClr val="8B96C2"/>
+                </a:solidFill>
+                <a:latin typeface="Arial" pitchFamily="34" charset="0"/>
+                <a:ea typeface="Arial" pitchFamily="34" charset="-122"/>
+                <a:cs typeface="Arial" pitchFamily="34" charset="-120"/>
+              </a:rPr>
+              <a:t>  for the live city  ·  </a:t>
+            </a:r>
+            <a:pPr algn="ctr" indent="0" marL="0">
+              <a:buNone/>
+            </a:pPr>
+            <a:r>
+              <a:rPr lang="en-US" sz="1500" b="1" dirty="0">
+                <a:solidFill>
+                  <a:srgbClr val="DFE6FF"/>
+                </a:solidFill>
+                <a:latin typeface="Arial" pitchFamily="34" charset="0"/>
+                <a:ea typeface="Arial" pitchFamily="34" charset="-122"/>
+                <a:cs typeface="Arial" pitchFamily="34" charset="-120"/>
+              </a:rPr>
+              <a:t>Gemini on Vertex</a:t>
+            </a:r>
+            <a:pPr algn="ctr" indent="0" marL="0">
+              <a:buNone/>
+            </a:pPr>
+            <a:r>
+              <a:rPr lang="en-US" sz="1500" dirty="0">
+                <a:solidFill>
+                  <a:srgbClr val="8B96C2"/>
+                </a:solidFill>
+                <a:latin typeface="Arial" pitchFamily="34" charset="0"/>
+                <a:ea typeface="Arial" pitchFamily="34" charset="-122"/>
+                <a:cs typeface="Arial" pitchFamily="34" charset="-120"/>
+              </a:rPr>
+              <a:t>  in the ring</a:t>
+            </a:r>
+            <a:endParaRPr lang="en-US" sz="1500" dirty="0"/>
+          </a:p>
+        </p:txBody>
+      </p:sp>
+      <p:sp>
+        <p:nvSpPr>
+          <p:cNvPr id="19" name="Text 17"/>
           <p:cNvSpPr txBox="1"/>
           <p:nvPr/>
         </p:nvSpPr>
         <p:spPr>
           <a:xfrm>
-            <a:off x="3246120" y="1417320"/>
-            <a:ext cx="1280160" cy="320040"/>
+            <a:off x="640080" y="5577840"/>
+            <a:ext cx="10972800" cy="457200"/>
           </a:xfrm>
           <a:prstGeom prst="rect">
             <a:avLst/>
@@ -2300,1337 +2697,17 @@
               <a:buNone/>
             </a:pPr>
             <a:r>
-              <a:rPr lang="en-US" sz="1050" i="1" dirty="0">
-                <a:solidFill>
-                  <a:srgbClr val="8B96C2"/>
+              <a:rPr lang="en-US" sz="1500" i="1" dirty="0">
+                <a:solidFill>
+                  <a:srgbClr val="FFB347"/>
                 </a:solidFill>
                 <a:latin typeface="Cambria" pitchFamily="34" charset="0"/>
                 <a:ea typeface="Cambria" pitchFamily="34" charset="-122"/>
                 <a:cs typeface="Cambria" pitchFamily="34" charset="-120"/>
               </a:rPr>
-              <a:t>POST /fight</a:t>
-            </a:r>
-            <a:endParaRPr lang="en-US" sz="1050" dirty="0"/>
-          </a:p>
-        </p:txBody>
-      </p:sp>
-      <p:sp>
-        <p:nvSpPr>
-          <p:cNvPr id="11" name="Shape 9"/>
-          <p:cNvSpPr/>
-          <p:nvPr/>
-        </p:nvSpPr>
-        <p:spPr>
-          <a:xfrm flipH="1">
-            <a:off x="4480560" y="2514600"/>
-            <a:ext cx="1188720" cy="0"/>
-          </a:xfrm>
-          <a:prstGeom prst="line">
-            <a:avLst/>
-          </a:prstGeom>
-          <a:noFill/>
-          <a:ln w="19050">
-            <a:solidFill>
-              <a:srgbClr val="8B96C2"/>
-            </a:solidFill>
-            <a:prstDash val="solid"/>
-            <a:tailEnd type="triangle"/>
-          </a:ln>
-        </p:spPr>
-      </p:sp>
-      <p:sp>
-        <p:nvSpPr>
-          <p:cNvPr id="12" name="Text 10"/>
-          <p:cNvSpPr txBox="1"/>
-          <p:nvPr/>
-        </p:nvSpPr>
-        <p:spPr>
-          <a:xfrm>
-            <a:off x="3108960" y="2651760"/>
-            <a:ext cx="1554480" cy="320040"/>
-          </a:xfrm>
-          <a:prstGeom prst="rect">
-            <a:avLst/>
-          </a:prstGeom>
-          <a:noFill/>
-          <a:ln/>
-        </p:spPr>
-        <p:txBody>
-          <a:bodyPr wrap="square" lIns="0" tIns="0" rIns="0" bIns="0" rtlCol="0" anchor="ctr"/>
-          <a:lstStyle/>
-          <a:p>
-            <a:pPr algn="ctr" indent="0" marL="0">
-              <a:buNone/>
-            </a:pPr>
-            <a:r>
-              <a:rPr lang="en-US" sz="1050" i="1" dirty="0">
-                <a:solidFill>
-                  <a:srgbClr val="8B96C2"/>
-                </a:solidFill>
-                <a:latin typeface="Cambria" pitchFamily="34" charset="0"/>
-                <a:ea typeface="Cambria" pitchFamily="34" charset="-122"/>
-                <a:cs typeface="Cambria" pitchFamily="34" charset="-120"/>
-              </a:rPr>
-              <a:t>SSE event stream</a:t>
-            </a:r>
-            <a:endParaRPr lang="en-US" sz="1050" dirty="0"/>
-          </a:p>
-        </p:txBody>
-      </p:sp>
-      <p:sp>
-        <p:nvSpPr>
-          <p:cNvPr id="13" name="Shape 11"/>
-          <p:cNvSpPr/>
-          <p:nvPr/>
-        </p:nvSpPr>
-        <p:spPr>
-          <a:xfrm>
-            <a:off x="3383280" y="3794760"/>
-            <a:ext cx="5394960" cy="2651760"/>
-          </a:xfrm>
-          <a:prstGeom prst="roundRect">
-            <a:avLst>
-              <a:gd name="adj" fmla="val 2759"/>
-            </a:avLst>
-          </a:prstGeom>
-          <a:solidFill>
-            <a:srgbClr val="141A2E"/>
-          </a:solidFill>
-          <a:ln w="15875">
-            <a:solidFill>
-              <a:srgbClr val="FFB347"/>
-            </a:solidFill>
-            <a:prstDash val="solid"/>
-          </a:ln>
-        </p:spPr>
-      </p:sp>
-      <p:sp>
-        <p:nvSpPr>
-          <p:cNvPr id="14" name="Text 12"/>
-          <p:cNvSpPr txBox="1"/>
-          <p:nvPr/>
-        </p:nvSpPr>
-        <p:spPr>
-          <a:xfrm>
-            <a:off x="3520440" y="3913632"/>
-            <a:ext cx="5120640" cy="320040"/>
-          </a:xfrm>
-          <a:prstGeom prst="rect">
-            <a:avLst/>
-          </a:prstGeom>
-          <a:noFill/>
-          <a:ln/>
-        </p:spPr>
-        <p:txBody>
-          <a:bodyPr wrap="square" lIns="0" tIns="0" rIns="0" bIns="0" rtlCol="0" anchor="ctr"/>
-          <a:lstStyle/>
-          <a:p>
-            <a:pPr algn="ctr" indent="0" marL="0">
-              <a:buNone/>
-            </a:pPr>
-            <a:r>
-              <a:rPr lang="en-US" sz="1300" b="1" dirty="0">
-                <a:solidFill>
-                  <a:srgbClr val="FFB347"/>
-                </a:solidFill>
-                <a:latin typeface="Arial" pitchFamily="34" charset="0"/>
-                <a:ea typeface="Arial" pitchFamily="34" charset="-122"/>
-                <a:cs typeface="Arial" pitchFamily="34" charset="-120"/>
-              </a:rPr>
-              <a:t>FIGHT HARNESS  (python subprocess · emits JSONL on stdout)</a:t>
-            </a:r>
-            <a:endParaRPr lang="en-US" sz="1300" dirty="0"/>
-          </a:p>
-        </p:txBody>
-      </p:sp>
-      <p:sp>
-        <p:nvSpPr>
-          <p:cNvPr id="15" name="Shape 13"/>
-          <p:cNvSpPr/>
-          <p:nvPr/>
-        </p:nvSpPr>
-        <p:spPr>
-          <a:xfrm>
-            <a:off x="3611880" y="4434840"/>
-            <a:ext cx="1600200" cy="1783080"/>
-          </a:xfrm>
-          <a:prstGeom prst="roundRect">
-            <a:avLst>
-              <a:gd name="adj" fmla="val 4571"/>
-            </a:avLst>
-          </a:prstGeom>
-          <a:solidFill>
-            <a:srgbClr val="141A2E"/>
-          </a:solidFill>
-          <a:ln w="15875">
-            <a:solidFill>
-              <a:srgbClr val="FFB347"/>
-            </a:solidFill>
-            <a:prstDash val="solid"/>
-          </a:ln>
-        </p:spPr>
-      </p:sp>
-      <p:sp>
-        <p:nvSpPr>
-          <p:cNvPr id="16" name="Text 14"/>
-          <p:cNvSpPr txBox="1"/>
-          <p:nvPr/>
-        </p:nvSpPr>
-        <p:spPr>
-          <a:xfrm>
-            <a:off x="3657600" y="4526280"/>
-            <a:ext cx="1508760" cy="320040"/>
-          </a:xfrm>
-          <a:prstGeom prst="rect">
-            <a:avLst/>
-          </a:prstGeom>
-          <a:noFill/>
-          <a:ln/>
-        </p:spPr>
-        <p:txBody>
-          <a:bodyPr wrap="square" lIns="0" tIns="0" rIns="0" bIns="0" rtlCol="0" anchor="ctr"/>
-          <a:lstStyle/>
-          <a:p>
-            <a:pPr algn="ctr" indent="0" marL="0">
-              <a:buNone/>
-            </a:pPr>
-            <a:r>
-              <a:rPr lang="en-US" sz="1200" b="1" dirty="0">
-                <a:solidFill>
-                  <a:srgbClr val="FFB347"/>
-                </a:solidFill>
-                <a:latin typeface="Arial" pitchFamily="34" charset="0"/>
-                <a:ea typeface="Arial" pitchFamily="34" charset="-122"/>
-                <a:cs typeface="Arial" pitchFamily="34" charset="-120"/>
-              </a:rPr>
-              <a:t>FIGHTER A</a:t>
-            </a:r>
-            <a:endParaRPr lang="en-US" sz="1200" dirty="0"/>
-          </a:p>
-        </p:txBody>
-      </p:sp>
-      <p:sp>
-        <p:nvSpPr>
-          <p:cNvPr id="17" name="Text 15"/>
-          <p:cNvSpPr txBox="1"/>
-          <p:nvPr/>
-        </p:nvSpPr>
-        <p:spPr>
-          <a:xfrm>
-            <a:off x="3657600" y="4864608"/>
-            <a:ext cx="1508760" cy="1234440"/>
-          </a:xfrm>
-          <a:prstGeom prst="rect">
-            <a:avLst/>
-          </a:prstGeom>
-          <a:noFill/>
-          <a:ln/>
-        </p:spPr>
-        <p:txBody>
-          <a:bodyPr wrap="square" lIns="0" tIns="0" rIns="0" bIns="0" rtlCol="0" anchor="ctr"/>
-          <a:lstStyle/>
-          <a:p>
-            <a:pPr algn="ctr" indent="0" marL="0">
-              <a:buNone/>
-            </a:pPr>
-            <a:r>
-              <a:rPr lang="en-US" sz="1050" dirty="0">
-                <a:solidFill>
-                  <a:srgbClr val="DFE6FF"/>
-                </a:solidFill>
-                <a:latin typeface="Arial" pitchFamily="34" charset="0"/>
-                <a:ea typeface="Arial" pitchFamily="34" charset="-122"/>
-                <a:cs typeface="Arial" pitchFamily="34" charset="-120"/>
-              </a:rPr>
-              <a:t>sandbox clone</a:t>
-            </a:r>
-            <a:endParaRPr lang="en-US" sz="1050" dirty="0"/>
-          </a:p>
-          <a:p>
-            <a:pPr algn="ctr" indent="0" marL="0">
-              <a:buNone/>
-            </a:pPr>
-            <a:r>
-              <a:rPr lang="en-US" sz="1050" dirty="0">
-                <a:solidFill>
-                  <a:srgbClr val="DFE6FF"/>
-                </a:solidFill>
-                <a:latin typeface="Arial" pitchFamily="34" charset="0"/>
-                <a:ea typeface="Arial" pitchFamily="34" charset="-122"/>
-                <a:cs typeface="Arial" pitchFamily="34" charset="-120"/>
-              </a:rPr>
-              <a:t>branch fight/a</a:t>
-            </a:r>
-            <a:endParaRPr lang="en-US" sz="1050" dirty="0"/>
-          </a:p>
-          <a:p>
-            <a:pPr algn="ctr" indent="0" marL="0">
-              <a:buNone/>
-            </a:pPr>
-            <a:r>
-              <a:rPr lang="en-US" sz="1050" dirty="0">
-                <a:solidFill>
-                  <a:srgbClr val="DFE6FF"/>
-                </a:solidFill>
-                <a:latin typeface="Arial" pitchFamily="34" charset="0"/>
-                <a:ea typeface="Arial" pitchFamily="34" charset="-122"/>
-                <a:cs typeface="Arial" pitchFamily="34" charset="-120"/>
-              </a:rPr>
-              <a:t>TrueFoundry</a:t>
-            </a:r>
-            <a:endParaRPr lang="en-US" sz="1050" dirty="0"/>
-          </a:p>
-          <a:p>
-            <a:pPr algn="ctr" indent="0" marL="0">
-              <a:buNone/>
-            </a:pPr>
-            <a:r>
-              <a:rPr lang="en-US" sz="1050" dirty="0">
-                <a:solidFill>
-                  <a:srgbClr val="DFE6FF"/>
-                </a:solidFill>
-                <a:latin typeface="Arial" pitchFamily="34" charset="0"/>
-                <a:ea typeface="Arial" pitchFamily="34" charset="-122"/>
-                <a:cs typeface="Arial" pitchFamily="34" charset="-120"/>
-              </a:rPr>
-              <a:t>gateway</a:t>
-            </a:r>
-            <a:endParaRPr lang="en-US" sz="1050" dirty="0"/>
-          </a:p>
-        </p:txBody>
-      </p:sp>
-      <p:sp>
-        <p:nvSpPr>
-          <p:cNvPr id="18" name="Shape 16"/>
-          <p:cNvSpPr/>
-          <p:nvPr/>
-        </p:nvSpPr>
-        <p:spPr>
-          <a:xfrm>
-            <a:off x="5303520" y="4434840"/>
-            <a:ext cx="1600200" cy="1783080"/>
-          </a:xfrm>
-          <a:prstGeom prst="roundRect">
-            <a:avLst>
-              <a:gd name="adj" fmla="val 4571"/>
-            </a:avLst>
-          </a:prstGeom>
-          <a:solidFill>
-            <a:srgbClr val="141A2E"/>
-          </a:solidFill>
-          <a:ln w="15875">
-            <a:solidFill>
-              <a:srgbClr val="7EC8FF"/>
-            </a:solidFill>
-            <a:prstDash val="solid"/>
-          </a:ln>
-        </p:spPr>
-      </p:sp>
-      <p:sp>
-        <p:nvSpPr>
-          <p:cNvPr id="19" name="Text 17"/>
-          <p:cNvSpPr txBox="1"/>
-          <p:nvPr/>
-        </p:nvSpPr>
-        <p:spPr>
-          <a:xfrm>
-            <a:off x="5349240" y="4526280"/>
-            <a:ext cx="1508760" cy="320040"/>
-          </a:xfrm>
-          <a:prstGeom prst="rect">
-            <a:avLst/>
-          </a:prstGeom>
-          <a:noFill/>
-          <a:ln/>
-        </p:spPr>
-        <p:txBody>
-          <a:bodyPr wrap="square" lIns="0" tIns="0" rIns="0" bIns="0" rtlCol="0" anchor="ctr"/>
-          <a:lstStyle/>
-          <a:p>
-            <a:pPr algn="ctr" indent="0" marL="0">
-              <a:buNone/>
-            </a:pPr>
-            <a:r>
-              <a:rPr lang="en-US" sz="1200" b="1" dirty="0">
-                <a:solidFill>
-                  <a:srgbClr val="7EC8FF"/>
-                </a:solidFill>
-                <a:latin typeface="Arial" pitchFamily="34" charset="0"/>
-                <a:ea typeface="Arial" pitchFamily="34" charset="-122"/>
-                <a:cs typeface="Arial" pitchFamily="34" charset="-120"/>
-              </a:rPr>
-              <a:t>FIGHTER B</a:t>
-            </a:r>
-            <a:endParaRPr lang="en-US" sz="1200" dirty="0"/>
-          </a:p>
-        </p:txBody>
-      </p:sp>
-      <p:sp>
-        <p:nvSpPr>
-          <p:cNvPr id="20" name="Text 18"/>
-          <p:cNvSpPr txBox="1"/>
-          <p:nvPr/>
-        </p:nvSpPr>
-        <p:spPr>
-          <a:xfrm>
-            <a:off x="5349240" y="4864608"/>
-            <a:ext cx="1508760" cy="1234440"/>
-          </a:xfrm>
-          <a:prstGeom prst="rect">
-            <a:avLst/>
-          </a:prstGeom>
-          <a:noFill/>
-          <a:ln/>
-        </p:spPr>
-        <p:txBody>
-          <a:bodyPr wrap="square" lIns="0" tIns="0" rIns="0" bIns="0" rtlCol="0" anchor="ctr"/>
-          <a:lstStyle/>
-          <a:p>
-            <a:pPr algn="ctr" indent="0" marL="0">
-              <a:buNone/>
-            </a:pPr>
-            <a:r>
-              <a:rPr lang="en-US" sz="1050" dirty="0">
-                <a:solidFill>
-                  <a:srgbClr val="DFE6FF"/>
-                </a:solidFill>
-                <a:latin typeface="Arial" pitchFamily="34" charset="0"/>
-                <a:ea typeface="Arial" pitchFamily="34" charset="-122"/>
-                <a:cs typeface="Arial" pitchFamily="34" charset="-120"/>
-              </a:rPr>
-              <a:t>sandbox clone</a:t>
-            </a:r>
-            <a:endParaRPr lang="en-US" sz="1050" dirty="0"/>
-          </a:p>
-          <a:p>
-            <a:pPr algn="ctr" indent="0" marL="0">
-              <a:buNone/>
-            </a:pPr>
-            <a:r>
-              <a:rPr lang="en-US" sz="1050" dirty="0">
-                <a:solidFill>
-                  <a:srgbClr val="DFE6FF"/>
-                </a:solidFill>
-                <a:latin typeface="Arial" pitchFamily="34" charset="0"/>
-                <a:ea typeface="Arial" pitchFamily="34" charset="-122"/>
-                <a:cs typeface="Arial" pitchFamily="34" charset="-120"/>
-              </a:rPr>
-              <a:t>branch fight/b</a:t>
-            </a:r>
-            <a:endParaRPr lang="en-US" sz="1050" dirty="0"/>
-          </a:p>
-          <a:p>
-            <a:pPr algn="ctr" indent="0" marL="0">
-              <a:buNone/>
-            </a:pPr>
-            <a:r>
-              <a:rPr lang="en-US" sz="1050" dirty="0">
-                <a:solidFill>
-                  <a:srgbClr val="DFE6FF"/>
-                </a:solidFill>
-                <a:latin typeface="Arial" pitchFamily="34" charset="0"/>
-                <a:ea typeface="Arial" pitchFamily="34" charset="-122"/>
-                <a:cs typeface="Arial" pitchFamily="34" charset="-120"/>
-              </a:rPr>
-              <a:t>OpenAI /</a:t>
-            </a:r>
-            <a:endParaRPr lang="en-US" sz="1050" dirty="0"/>
-          </a:p>
-          <a:p>
-            <a:pPr algn="ctr" indent="0" marL="0">
-              <a:buNone/>
-            </a:pPr>
-            <a:r>
-              <a:rPr lang="en-US" sz="1050" dirty="0">
-                <a:solidFill>
-                  <a:srgbClr val="DFE6FF"/>
-                </a:solidFill>
-                <a:latin typeface="Arial" pitchFamily="34" charset="0"/>
-                <a:ea typeface="Arial" pitchFamily="34" charset="-122"/>
-                <a:cs typeface="Arial" pitchFamily="34" charset="-120"/>
-              </a:rPr>
-              <a:t>Gemini Vertex</a:t>
-            </a:r>
-            <a:endParaRPr lang="en-US" sz="1050" dirty="0"/>
-          </a:p>
-        </p:txBody>
-      </p:sp>
-      <p:sp>
-        <p:nvSpPr>
-          <p:cNvPr id="21" name="Shape 19"/>
-          <p:cNvSpPr/>
-          <p:nvPr/>
-        </p:nvSpPr>
-        <p:spPr>
-          <a:xfrm>
-            <a:off x="6995160" y="4434840"/>
-            <a:ext cx="1600200" cy="1783080"/>
-          </a:xfrm>
-          <a:prstGeom prst="roundRect">
-            <a:avLst>
-              <a:gd name="adj" fmla="val 4571"/>
-            </a:avLst>
-          </a:prstGeom>
-          <a:solidFill>
-            <a:srgbClr val="141A2E"/>
-          </a:solidFill>
-          <a:ln w="15875">
-            <a:solidFill>
-              <a:srgbClr val="C9A5FF"/>
-            </a:solidFill>
-            <a:prstDash val="solid"/>
-          </a:ln>
-        </p:spPr>
-      </p:sp>
-      <p:sp>
-        <p:nvSpPr>
-          <p:cNvPr id="22" name="Text 20"/>
-          <p:cNvSpPr txBox="1"/>
-          <p:nvPr/>
-        </p:nvSpPr>
-        <p:spPr>
-          <a:xfrm>
-            <a:off x="7040880" y="4526280"/>
-            <a:ext cx="1508760" cy="320040"/>
-          </a:xfrm>
-          <a:prstGeom prst="rect">
-            <a:avLst/>
-          </a:prstGeom>
-          <a:noFill/>
-          <a:ln/>
-        </p:spPr>
-        <p:txBody>
-          <a:bodyPr wrap="square" lIns="0" tIns="0" rIns="0" bIns="0" rtlCol="0" anchor="ctr"/>
-          <a:lstStyle/>
-          <a:p>
-            <a:pPr algn="ctr" indent="0" marL="0">
-              <a:buNone/>
-            </a:pPr>
-            <a:r>
-              <a:rPr lang="en-US" sz="1200" b="1" dirty="0">
-                <a:solidFill>
-                  <a:srgbClr val="C9A5FF"/>
-                </a:solidFill>
-                <a:latin typeface="Arial" pitchFamily="34" charset="0"/>
-                <a:ea typeface="Arial" pitchFamily="34" charset="-122"/>
-                <a:cs typeface="Arial" pitchFamily="34" charset="-120"/>
-              </a:rPr>
-              <a:t>REFEREE</a:t>
-            </a:r>
-            <a:endParaRPr lang="en-US" sz="1200" dirty="0"/>
-          </a:p>
-        </p:txBody>
-      </p:sp>
-      <p:sp>
-        <p:nvSpPr>
-          <p:cNvPr id="23" name="Text 21"/>
-          <p:cNvSpPr txBox="1"/>
-          <p:nvPr/>
-        </p:nvSpPr>
-        <p:spPr>
-          <a:xfrm>
-            <a:off x="7040880" y="4864608"/>
-            <a:ext cx="1508760" cy="1234440"/>
-          </a:xfrm>
-          <a:prstGeom prst="rect">
-            <a:avLst/>
-          </a:prstGeom>
-          <a:noFill/>
-          <a:ln/>
-        </p:spPr>
-        <p:txBody>
-          <a:bodyPr wrap="square" lIns="0" tIns="0" rIns="0" bIns="0" rtlCol="0" anchor="ctr"/>
-          <a:lstStyle/>
-          <a:p>
-            <a:pPr algn="ctr" indent="0" marL="0">
-              <a:buNone/>
-            </a:pPr>
-            <a:r>
-              <a:rPr lang="en-US" sz="1050" dirty="0">
-                <a:solidFill>
-                  <a:srgbClr val="DFE6FF"/>
-                </a:solidFill>
-                <a:latin typeface="Arial" pitchFamily="34" charset="0"/>
-                <a:ea typeface="Arial" pitchFamily="34" charset="-122"/>
-                <a:cs typeface="Arial" pitchFamily="34" charset="-120"/>
-              </a:rPr>
-              <a:t>clean 4th clone</a:t>
-            </a:r>
-            <a:endParaRPr lang="en-US" sz="1050" dirty="0"/>
-          </a:p>
-          <a:p>
-            <a:pPr algn="ctr" indent="0" marL="0">
-              <a:buNone/>
-            </a:pPr>
-            <a:r>
-              <a:rPr lang="en-US" sz="1050" dirty="0">
-                <a:solidFill>
-                  <a:srgbClr val="DFE6FF"/>
-                </a:solidFill>
-                <a:latin typeface="Arial" pitchFamily="34" charset="0"/>
-                <a:ea typeface="Arial" pitchFamily="34" charset="-122"/>
-                <a:cs typeface="Arial" pitchFamily="34" charset="-120"/>
-              </a:rPr>
-              <a:t>re-runs MAIN's</a:t>
-            </a:r>
-            <a:endParaRPr lang="en-US" sz="1050" dirty="0"/>
-          </a:p>
-          <a:p>
-            <a:pPr algn="ctr" indent="0" marL="0">
-              <a:buNone/>
-            </a:pPr>
-            <a:r>
-              <a:rPr lang="en-US" sz="1050" dirty="0">
-                <a:solidFill>
-                  <a:srgbClr val="DFE6FF"/>
-                </a:solidFill>
-                <a:latin typeface="Arial" pitchFamily="34" charset="0"/>
-                <a:ea typeface="Arial" pitchFamily="34" charset="-122"/>
-                <a:cs typeface="Arial" pitchFamily="34" charset="-120"/>
-              </a:rPr>
-              <a:t>tests · reviews</a:t>
-            </a:r>
-            <a:endParaRPr lang="en-US" sz="1050" dirty="0"/>
-          </a:p>
-          <a:p>
-            <a:pPr algn="ctr" indent="0" marL="0">
-              <a:buNone/>
-            </a:pPr>
-            <a:r>
-              <a:rPr lang="en-US" sz="1050" dirty="0">
-                <a:solidFill>
-                  <a:srgbClr val="DFE6FF"/>
-                </a:solidFill>
-                <a:latin typeface="Arial" pitchFamily="34" charset="0"/>
-                <a:ea typeface="Arial" pitchFamily="34" charset="-122"/>
-                <a:cs typeface="Arial" pitchFamily="34" charset="-120"/>
-              </a:rPr>
-              <a:t>diffs · scores</a:t>
-            </a:r>
-            <a:endParaRPr lang="en-US" sz="1050" dirty="0"/>
-          </a:p>
-        </p:txBody>
-      </p:sp>
-      <p:sp>
-        <p:nvSpPr>
-          <p:cNvPr id="24" name="Shape 22"/>
-          <p:cNvSpPr/>
-          <p:nvPr/>
-        </p:nvSpPr>
-        <p:spPr>
-          <a:xfrm>
-            <a:off x="6035040" y="3291840"/>
-            <a:ext cx="0" cy="502920"/>
-          </a:xfrm>
-          <a:prstGeom prst="line">
-            <a:avLst/>
-          </a:prstGeom>
-          <a:noFill/>
-          <a:ln w="19050">
-            <a:solidFill>
-              <a:srgbClr val="8B96C2"/>
-            </a:solidFill>
-            <a:prstDash val="solid"/>
-            <a:tailEnd type="triangle"/>
-          </a:ln>
-        </p:spPr>
-      </p:sp>
-      <p:sp>
-        <p:nvSpPr>
-          <p:cNvPr id="25" name="Text 23"/>
-          <p:cNvSpPr txBox="1"/>
-          <p:nvPr/>
-        </p:nvSpPr>
-        <p:spPr>
-          <a:xfrm>
-            <a:off x="6172200" y="3310128"/>
-            <a:ext cx="1828800" cy="320040"/>
-          </a:xfrm>
-          <a:prstGeom prst="rect">
-            <a:avLst/>
-          </a:prstGeom>
-          <a:noFill/>
-          <a:ln/>
-        </p:spPr>
-        <p:txBody>
-          <a:bodyPr wrap="square" lIns="0" tIns="0" rIns="0" bIns="0" rtlCol="0" anchor="ctr"/>
-          <a:lstStyle/>
-          <a:p>
-            <a:pPr algn="ctr" indent="0" marL="0">
-              <a:buNone/>
-            </a:pPr>
-            <a:r>
-              <a:rPr lang="en-US" sz="1050" i="1" dirty="0">
-                <a:solidFill>
-                  <a:srgbClr val="8B96C2"/>
-                </a:solidFill>
-                <a:latin typeface="Cambria" pitchFamily="34" charset="0"/>
-                <a:ea typeface="Cambria" pitchFamily="34" charset="-122"/>
-                <a:cs typeface="Cambria" pitchFamily="34" charset="-120"/>
-              </a:rPr>
-              <a:t>spawn · pipe stdout</a:t>
-            </a:r>
-            <a:endParaRPr lang="en-US" sz="1050" dirty="0"/>
-          </a:p>
-        </p:txBody>
-      </p:sp>
-      <p:sp>
-        <p:nvSpPr>
-          <p:cNvPr id="26" name="Shape 24"/>
-          <p:cNvSpPr/>
-          <p:nvPr/>
-        </p:nvSpPr>
-        <p:spPr>
-          <a:xfrm>
-            <a:off x="9418320" y="868680"/>
-            <a:ext cx="2240280" cy="1371600"/>
-          </a:xfrm>
-          <a:prstGeom prst="roundRect">
-            <a:avLst>
-              <a:gd name="adj" fmla="val 5333"/>
-            </a:avLst>
-          </a:prstGeom>
-          <a:solidFill>
-            <a:srgbClr val="141A2E"/>
-          </a:solidFill>
-          <a:ln w="15875">
-            <a:solidFill>
-              <a:srgbClr val="6FE3A1"/>
-            </a:solidFill>
-            <a:prstDash val="solid"/>
-          </a:ln>
-        </p:spPr>
-      </p:sp>
-      <p:sp>
-        <p:nvSpPr>
-          <p:cNvPr id="27" name="Text 25"/>
-          <p:cNvSpPr txBox="1"/>
-          <p:nvPr/>
-        </p:nvSpPr>
-        <p:spPr>
-          <a:xfrm>
-            <a:off x="9509760" y="969264"/>
-            <a:ext cx="2057400" cy="320040"/>
-          </a:xfrm>
-          <a:prstGeom prst="rect">
-            <a:avLst/>
-          </a:prstGeom>
-          <a:noFill/>
-          <a:ln/>
-        </p:spPr>
-        <p:txBody>
-          <a:bodyPr wrap="square" lIns="0" tIns="0" rIns="0" bIns="0" rtlCol="0" anchor="ctr"/>
-          <a:lstStyle/>
-          <a:p>
-            <a:pPr algn="ctr" indent="0" marL="0">
-              <a:buNone/>
-            </a:pPr>
-            <a:r>
-              <a:rPr lang="en-US" sz="1300" b="1" dirty="0">
-                <a:solidFill>
-                  <a:srgbClr val="6FE3A1"/>
-                </a:solidFill>
-                <a:latin typeface="Arial" pitchFamily="34" charset="0"/>
-                <a:ea typeface="Arial" pitchFamily="34" charset="-122"/>
-                <a:cs typeface="Arial" pitchFamily="34" charset="-120"/>
-              </a:rPr>
-              <a:t>GITHUB</a:t>
-            </a:r>
-            <a:endParaRPr lang="en-US" sz="1300" dirty="0"/>
-          </a:p>
-        </p:txBody>
-      </p:sp>
-      <p:sp>
-        <p:nvSpPr>
-          <p:cNvPr id="28" name="Text 26"/>
-          <p:cNvSpPr txBox="1"/>
-          <p:nvPr/>
-        </p:nvSpPr>
-        <p:spPr>
-          <a:xfrm>
-            <a:off x="9509760" y="1325880"/>
-            <a:ext cx="2057400" cy="731520"/>
-          </a:xfrm>
-          <a:prstGeom prst="rect">
-            <a:avLst/>
-          </a:prstGeom>
-          <a:noFill/>
-          <a:ln/>
-        </p:spPr>
-        <p:txBody>
-          <a:bodyPr wrap="square" lIns="0" tIns="0" rIns="0" bIns="0" rtlCol="0" anchor="ctr"/>
-          <a:lstStyle/>
-          <a:p>
-            <a:pPr algn="ctr" indent="0" marL="0">
-              <a:buNone/>
-            </a:pPr>
-            <a:r>
-              <a:rPr lang="en-US" sz="1100" dirty="0">
-                <a:solidFill>
-                  <a:srgbClr val="DFE6FF"/>
-                </a:solidFill>
-                <a:latin typeface="Arial" pitchFamily="34" charset="0"/>
-                <a:ea typeface="Arial" pitchFamily="34" charset="-122"/>
-                <a:cs typeface="Arial" pitchFamily="34" charset="-120"/>
-              </a:rPr>
-              <a:t>winner's PR opened</a:t>
-            </a:r>
-            <a:endParaRPr lang="en-US" sz="1100" dirty="0"/>
-          </a:p>
-          <a:p>
-            <a:pPr algn="ctr" indent="0" marL="0">
-              <a:buNone/>
-            </a:pPr>
-            <a:r>
-              <a:rPr lang="en-US" sz="1100" dirty="0">
-                <a:solidFill>
-                  <a:srgbClr val="DFE6FF"/>
-                </a:solidFill>
-                <a:latin typeface="Arial" pitchFamily="34" charset="0"/>
-                <a:ea typeface="Arial" pitchFamily="34" charset="-122"/>
-                <a:cs typeface="Arial" pitchFamily="34" charset="-120"/>
-              </a:rPr>
-              <a:t>loser's branch deleted</a:t>
-            </a:r>
-            <a:endParaRPr lang="en-US" sz="1100" dirty="0"/>
-          </a:p>
-        </p:txBody>
-      </p:sp>
-      <p:sp>
-        <p:nvSpPr>
-          <p:cNvPr id="29" name="Shape 27"/>
-          <p:cNvSpPr/>
-          <p:nvPr/>
-        </p:nvSpPr>
-        <p:spPr>
-          <a:xfrm>
-            <a:off x="9418320" y="2514600"/>
-            <a:ext cx="2240280" cy="1371600"/>
-          </a:xfrm>
-          <a:prstGeom prst="roundRect">
-            <a:avLst>
-              <a:gd name="adj" fmla="val 5333"/>
-            </a:avLst>
-          </a:prstGeom>
-          <a:solidFill>
-            <a:srgbClr val="141A2E"/>
-          </a:solidFill>
-          <a:ln w="15875">
-            <a:solidFill>
-              <a:srgbClr val="7EC8FF"/>
-            </a:solidFill>
-            <a:prstDash val="solid"/>
-          </a:ln>
-        </p:spPr>
-      </p:sp>
-      <p:sp>
-        <p:nvSpPr>
-          <p:cNvPr id="30" name="Text 28"/>
-          <p:cNvSpPr txBox="1"/>
-          <p:nvPr/>
-        </p:nvSpPr>
-        <p:spPr>
-          <a:xfrm>
-            <a:off x="9509760" y="2615184"/>
-            <a:ext cx="2057400" cy="320040"/>
-          </a:xfrm>
-          <a:prstGeom prst="rect">
-            <a:avLst/>
-          </a:prstGeom>
-          <a:noFill/>
-          <a:ln/>
-        </p:spPr>
-        <p:txBody>
-          <a:bodyPr wrap="square" lIns="0" tIns="0" rIns="0" bIns="0" rtlCol="0" anchor="ctr"/>
-          <a:lstStyle/>
-          <a:p>
-            <a:pPr algn="ctr" indent="0" marL="0">
-              <a:buNone/>
-            </a:pPr>
-            <a:r>
-              <a:rPr lang="en-US" sz="1300" b="1" dirty="0">
-                <a:solidFill>
-                  <a:srgbClr val="7EC8FF"/>
-                </a:solidFill>
-                <a:latin typeface="Arial" pitchFamily="34" charset="0"/>
-                <a:ea typeface="Arial" pitchFamily="34" charset="-122"/>
-                <a:cs typeface="Arial" pitchFamily="34" charset="-120"/>
-              </a:rPr>
-              <a:t>BRIGHT DATA</a:t>
-            </a:r>
-            <a:endParaRPr lang="en-US" sz="1300" dirty="0"/>
-          </a:p>
-        </p:txBody>
-      </p:sp>
-      <p:sp>
-        <p:nvSpPr>
-          <p:cNvPr id="31" name="Text 29"/>
-          <p:cNvSpPr txBox="1"/>
-          <p:nvPr/>
-        </p:nvSpPr>
-        <p:spPr>
-          <a:xfrm>
-            <a:off x="9509760" y="2971800"/>
-            <a:ext cx="2057400" cy="731520"/>
-          </a:xfrm>
-          <a:prstGeom prst="rect">
-            <a:avLst/>
-          </a:prstGeom>
-          <a:noFill/>
-          <a:ln/>
-        </p:spPr>
-        <p:txBody>
-          <a:bodyPr wrap="square" lIns="0" tIns="0" rIns="0" bIns="0" rtlCol="0" anchor="ctr"/>
-          <a:lstStyle/>
-          <a:p>
-            <a:pPr algn="ctr" indent="0" marL="0">
-              <a:buNone/>
-            </a:pPr>
-            <a:r>
-              <a:rPr lang="en-US" sz="1100" dirty="0">
-                <a:solidFill>
-                  <a:srgbClr val="DFE6FF"/>
-                </a:solidFill>
-                <a:latin typeface="Arial" pitchFamily="34" charset="0"/>
-                <a:ea typeface="Arial" pitchFamily="34" charset="-122"/>
-                <a:cs typeface="Arial" pitchFamily="34" charset="-120"/>
-              </a:rPr>
-              <a:t>Web Unlocker scrapes</a:t>
-            </a:r>
-            <a:endParaRPr lang="en-US" sz="1100" dirty="0"/>
-          </a:p>
-          <a:p>
-            <a:pPr algn="ctr" indent="0" marL="0">
-              <a:buNone/>
-            </a:pPr>
-            <a:r>
-              <a:rPr lang="en-US" sz="1100" dirty="0">
-                <a:solidFill>
-                  <a:srgbClr val="DFE6FF"/>
-                </a:solidFill>
-                <a:latin typeface="Arial" pitchFamily="34" charset="0"/>
-                <a:ea typeface="Arial" pitchFamily="34" charset="-122"/>
-                <a:cs typeface="Arial" pitchFamily="34" charset="-120"/>
-              </a:rPr>
-              <a:t>GitHub → repos.json</a:t>
-            </a:r>
-            <a:endParaRPr lang="en-US" sz="1100" dirty="0"/>
-          </a:p>
-        </p:txBody>
-      </p:sp>
-      <p:sp>
-        <p:nvSpPr>
-          <p:cNvPr id="32" name="Shape 30"/>
-          <p:cNvSpPr/>
-          <p:nvPr/>
-        </p:nvSpPr>
-        <p:spPr>
-          <a:xfrm>
-            <a:off x="9418320" y="4160520"/>
-            <a:ext cx="2240280" cy="1371600"/>
-          </a:xfrm>
-          <a:prstGeom prst="roundRect">
-            <a:avLst>
-              <a:gd name="adj" fmla="val 5333"/>
-            </a:avLst>
-          </a:prstGeom>
-          <a:solidFill>
-            <a:srgbClr val="141A2E"/>
-          </a:solidFill>
-          <a:ln w="15875">
-            <a:solidFill>
-              <a:srgbClr val="FFB347"/>
-            </a:solidFill>
-            <a:prstDash val="solid"/>
-          </a:ln>
-        </p:spPr>
-      </p:sp>
-      <p:sp>
-        <p:nvSpPr>
-          <p:cNvPr id="33" name="Text 31"/>
-          <p:cNvSpPr txBox="1"/>
-          <p:nvPr/>
-        </p:nvSpPr>
-        <p:spPr>
-          <a:xfrm>
-            <a:off x="9509760" y="4261104"/>
-            <a:ext cx="2057400" cy="320040"/>
-          </a:xfrm>
-          <a:prstGeom prst="rect">
-            <a:avLst/>
-          </a:prstGeom>
-          <a:noFill/>
-          <a:ln/>
-        </p:spPr>
-        <p:txBody>
-          <a:bodyPr wrap="square" lIns="0" tIns="0" rIns="0" bIns="0" rtlCol="0" anchor="ctr"/>
-          <a:lstStyle/>
-          <a:p>
-            <a:pPr algn="ctr" indent="0" marL="0">
-              <a:buNone/>
-            </a:pPr>
-            <a:r>
-              <a:rPr lang="en-US" sz="1300" b="1" dirty="0">
-                <a:solidFill>
-                  <a:srgbClr val="FFB347"/>
-                </a:solidFill>
-                <a:latin typeface="Arial" pitchFamily="34" charset="0"/>
-                <a:ea typeface="Arial" pitchFamily="34" charset="-122"/>
-                <a:cs typeface="Arial" pitchFamily="34" charset="-120"/>
-              </a:rPr>
-              <a:t>CLICKHOUSE</a:t>
-            </a:r>
-            <a:endParaRPr lang="en-US" sz="1300" dirty="0"/>
-          </a:p>
-        </p:txBody>
-      </p:sp>
-      <p:sp>
-        <p:nvSpPr>
-          <p:cNvPr id="34" name="Text 32"/>
-          <p:cNvSpPr txBox="1"/>
-          <p:nvPr/>
-        </p:nvSpPr>
-        <p:spPr>
-          <a:xfrm>
-            <a:off x="9509760" y="4617720"/>
-            <a:ext cx="2057400" cy="731520"/>
-          </a:xfrm>
-          <a:prstGeom prst="rect">
-            <a:avLst/>
-          </a:prstGeom>
-          <a:noFill/>
-          <a:ln/>
-        </p:spPr>
-        <p:txBody>
-          <a:bodyPr wrap="square" lIns="0" tIns="0" rIns="0" bIns="0" rtlCol="0" anchor="ctr"/>
-          <a:lstStyle/>
-          <a:p>
-            <a:pPr algn="ctr" indent="0" marL="0">
-              <a:buNone/>
-            </a:pPr>
-            <a:r>
-              <a:rPr lang="en-US" sz="1100" dirty="0">
-                <a:solidFill>
-                  <a:srgbClr val="DFE6FF"/>
-                </a:solidFill>
-                <a:latin typeface="Arial" pitchFamily="34" charset="0"/>
-                <a:ea typeface="Arial" pitchFamily="34" charset="-122"/>
-                <a:cs typeface="Arial" pitchFamily="34" charset="-120"/>
-              </a:rPr>
-              <a:t>every event inserted</a:t>
-            </a:r>
-            <a:endParaRPr lang="en-US" sz="1100" dirty="0"/>
-          </a:p>
-          <a:p>
-            <a:pPr algn="ctr" indent="0" marL="0">
-              <a:buNone/>
-            </a:pPr>
-            <a:r>
-              <a:rPr lang="en-US" sz="1100" dirty="0">
-                <a:solidFill>
-                  <a:srgbClr val="DFE6FF"/>
-                </a:solidFill>
-                <a:latin typeface="Arial" pitchFamily="34" charset="0"/>
-                <a:ea typeface="Arial" pitchFamily="34" charset="-122"/>
-                <a:cs typeface="Arial" pitchFamily="34" charset="-120"/>
-              </a:rPr>
-              <a:t>JSONEachRow · /stats</a:t>
-            </a:r>
-            <a:endParaRPr lang="en-US" sz="1100" dirty="0"/>
-          </a:p>
-        </p:txBody>
-      </p:sp>
-      <p:sp>
-        <p:nvSpPr>
-          <p:cNvPr id="35" name="Shape 33"/>
-          <p:cNvSpPr/>
-          <p:nvPr/>
-        </p:nvSpPr>
-        <p:spPr>
-          <a:xfrm>
-            <a:off x="9418320" y="5806440"/>
-            <a:ext cx="2240280" cy="777240"/>
-          </a:xfrm>
-          <a:prstGeom prst="roundRect">
-            <a:avLst>
-              <a:gd name="adj" fmla="val 9412"/>
-            </a:avLst>
-          </a:prstGeom>
-          <a:solidFill>
-            <a:srgbClr val="141A2E"/>
-          </a:solidFill>
-          <a:ln w="15875">
-            <a:solidFill>
-              <a:srgbClr val="C9A5FF"/>
-            </a:solidFill>
-            <a:prstDash val="solid"/>
-          </a:ln>
-        </p:spPr>
-      </p:sp>
-      <p:sp>
-        <p:nvSpPr>
-          <p:cNvPr id="36" name="Text 34"/>
-          <p:cNvSpPr txBox="1"/>
-          <p:nvPr/>
-        </p:nvSpPr>
-        <p:spPr>
-          <a:xfrm>
-            <a:off x="9509760" y="5888736"/>
-            <a:ext cx="2057400" cy="320040"/>
-          </a:xfrm>
-          <a:prstGeom prst="rect">
-            <a:avLst/>
-          </a:prstGeom>
-          <a:noFill/>
-          <a:ln/>
-        </p:spPr>
-        <p:txBody>
-          <a:bodyPr wrap="square" lIns="0" tIns="0" rIns="0" bIns="0" rtlCol="0" anchor="ctr"/>
-          <a:lstStyle/>
-          <a:p>
-            <a:pPr algn="ctr" indent="0" marL="0">
-              <a:buNone/>
-            </a:pPr>
-            <a:r>
-              <a:rPr lang="en-US" sz="1300" b="1" dirty="0">
-                <a:solidFill>
-                  <a:srgbClr val="C9A5FF"/>
-                </a:solidFill>
-                <a:latin typeface="Arial" pitchFamily="34" charset="0"/>
-                <a:ea typeface="Arial" pitchFamily="34" charset="-122"/>
-                <a:cs typeface="Arial" pitchFamily="34" charset="-120"/>
-              </a:rPr>
-              <a:t>QODO</a:t>
-            </a:r>
-            <a:endParaRPr lang="en-US" sz="1300" dirty="0"/>
-          </a:p>
-        </p:txBody>
-      </p:sp>
-      <p:sp>
-        <p:nvSpPr>
-          <p:cNvPr id="37" name="Text 35"/>
-          <p:cNvSpPr txBox="1"/>
-          <p:nvPr/>
-        </p:nvSpPr>
-        <p:spPr>
-          <a:xfrm>
-            <a:off x="9509760" y="6217920"/>
-            <a:ext cx="2057400" cy="320040"/>
-          </a:xfrm>
-          <a:prstGeom prst="rect">
-            <a:avLst/>
-          </a:prstGeom>
-          <a:noFill/>
-          <a:ln/>
-        </p:spPr>
-        <p:txBody>
-          <a:bodyPr wrap="square" lIns="0" tIns="0" rIns="0" bIns="0" rtlCol="0" anchor="ctr"/>
-          <a:lstStyle/>
-          <a:p>
-            <a:pPr algn="ctr" indent="0" marL="0">
-              <a:buNone/>
-            </a:pPr>
-            <a:r>
-              <a:rPr lang="en-US" sz="1050" dirty="0">
-                <a:solidFill>
-                  <a:srgbClr val="DFE6FF"/>
-                </a:solidFill>
-                <a:latin typeface="Arial" pitchFamily="34" charset="0"/>
-                <a:ea typeface="Arial" pitchFamily="34" charset="-122"/>
-                <a:cs typeface="Arial" pitchFamily="34" charset="-120"/>
-              </a:rPr>
-              <a:t>reviews every PR merged</a:t>
-            </a:r>
-            <a:endParaRPr lang="en-US" sz="1050" dirty="0"/>
-          </a:p>
-        </p:txBody>
-      </p:sp>
-      <p:sp>
-        <p:nvSpPr>
-          <p:cNvPr id="38" name="Shape 36"/>
-          <p:cNvSpPr/>
-          <p:nvPr/>
-        </p:nvSpPr>
-        <p:spPr>
-          <a:xfrm>
-            <a:off x="8778240" y="5029200"/>
-            <a:ext cx="640080" cy="-3291840"/>
-          </a:xfrm>
-          <a:prstGeom prst="line">
-            <a:avLst/>
-          </a:prstGeom>
-          <a:noFill/>
-          <a:ln w="19050">
-            <a:solidFill>
-              <a:srgbClr val="8B96C2"/>
-            </a:solidFill>
-            <a:prstDash val="solid"/>
-            <a:tailEnd type="triangle"/>
-          </a:ln>
-        </p:spPr>
-      </p:sp>
-      <p:sp>
-        <p:nvSpPr>
-          <p:cNvPr id="39" name="Text 37"/>
-          <p:cNvSpPr txBox="1"/>
-          <p:nvPr/>
-        </p:nvSpPr>
-        <p:spPr>
-          <a:xfrm>
-            <a:off x="7818120" y="3657600"/>
-            <a:ext cx="1920240" cy="320040"/>
-          </a:xfrm>
-          <a:prstGeom prst="rect">
-            <a:avLst/>
-          </a:prstGeom>
-          <a:noFill/>
-          <a:ln/>
-        </p:spPr>
-        <p:txBody>
-          <a:bodyPr wrap="square" lIns="0" tIns="0" rIns="0" bIns="0" rtlCol="0" anchor="ctr"/>
-          <a:lstStyle/>
-          <a:p>
-            <a:pPr algn="ctr" indent="0" marL="0">
-              <a:buNone/>
-            </a:pPr>
-            <a:r>
-              <a:rPr lang="en-US" sz="1050" i="1" dirty="0">
-                <a:solidFill>
-                  <a:srgbClr val="8B96C2"/>
-                </a:solidFill>
-                <a:latin typeface="Cambria" pitchFamily="34" charset="0"/>
-                <a:ea typeface="Cambria" pitchFamily="34" charset="-122"/>
-                <a:cs typeface="Cambria" pitchFamily="34" charset="-120"/>
-              </a:rPr>
-              <a:t>git push · gh pr create</a:t>
-            </a:r>
-            <a:endParaRPr lang="en-US" sz="1050" dirty="0"/>
-          </a:p>
-        </p:txBody>
-      </p:sp>
-      <p:sp>
-        <p:nvSpPr>
-          <p:cNvPr id="40" name="Shape 38"/>
-          <p:cNvSpPr/>
-          <p:nvPr/>
-        </p:nvSpPr>
-        <p:spPr>
-          <a:xfrm flipH="1">
-            <a:off x="9418320" y="3200400"/>
-            <a:ext cx="-1828800" cy="-1097280"/>
-          </a:xfrm>
-          <a:prstGeom prst="line">
-            <a:avLst/>
-          </a:prstGeom>
-          <a:noFill/>
-          <a:ln w="19050">
-            <a:solidFill>
-              <a:srgbClr val="8B96C2"/>
-            </a:solidFill>
-            <a:prstDash val="solid"/>
-            <a:tailEnd type="triangle"/>
-          </a:ln>
-        </p:spPr>
-      </p:sp>
-      <p:sp>
-        <p:nvSpPr>
-          <p:cNvPr id="41" name="Shape 39"/>
-          <p:cNvSpPr/>
-          <p:nvPr/>
-        </p:nvSpPr>
-        <p:spPr>
-          <a:xfrm>
-            <a:off x="7589520" y="3017520"/>
-            <a:ext cx="1828800" cy="1828800"/>
-          </a:xfrm>
-          <a:prstGeom prst="line">
-            <a:avLst/>
-          </a:prstGeom>
-          <a:noFill/>
-          <a:ln w="19050">
-            <a:solidFill>
-              <a:srgbClr val="8B96C2"/>
-            </a:solidFill>
-            <a:prstDash val="solid"/>
-            <a:tailEnd type="triangle"/>
-          </a:ln>
-        </p:spPr>
-      </p:sp>
-      <p:sp>
-        <p:nvSpPr>
-          <p:cNvPr id="42" name="Text 40"/>
-          <p:cNvSpPr txBox="1"/>
-          <p:nvPr/>
-        </p:nvSpPr>
-        <p:spPr>
-          <a:xfrm>
-            <a:off x="8549640" y="3977640"/>
-            <a:ext cx="914400" cy="320040"/>
-          </a:xfrm>
-          <a:prstGeom prst="rect">
-            <a:avLst/>
-          </a:prstGeom>
-          <a:noFill/>
-          <a:ln/>
-        </p:spPr>
-        <p:txBody>
-          <a:bodyPr wrap="square" lIns="0" tIns="0" rIns="0" bIns="0" rtlCol="0" anchor="ctr"/>
-          <a:lstStyle/>
-          <a:p>
-            <a:pPr algn="ctr" indent="0" marL="0">
-              <a:buNone/>
-            </a:pPr>
-            <a:r>
-              <a:rPr lang="en-US" sz="1050" i="1" dirty="0">
-                <a:solidFill>
-                  <a:srgbClr val="8B96C2"/>
-                </a:solidFill>
-                <a:latin typeface="Cambria" pitchFamily="34" charset="0"/>
-                <a:ea typeface="Cambria" pitchFamily="34" charset="-122"/>
-                <a:cs typeface="Cambria" pitchFamily="34" charset="-120"/>
-              </a:rPr>
-              <a:t>events</a:t>
-            </a:r>
-            <a:endParaRPr lang="en-US" sz="1050" dirty="0"/>
-          </a:p>
-        </p:txBody>
-      </p:sp>
-      <p:sp>
-        <p:nvSpPr>
-          <p:cNvPr id="43" name="Text 41"/>
-          <p:cNvSpPr txBox="1"/>
-          <p:nvPr/>
-        </p:nvSpPr>
-        <p:spPr>
-          <a:xfrm>
-            <a:off x="548640" y="6446520"/>
-            <a:ext cx="8595360" cy="365760"/>
-          </a:xfrm>
-          <a:prstGeom prst="rect">
-            <a:avLst/>
-          </a:prstGeom>
-          <a:noFill/>
-          <a:ln/>
-        </p:spPr>
-        <p:txBody>
-          <a:bodyPr wrap="square" lIns="0" tIns="0" rIns="0" bIns="0" rtlCol="0" anchor="ctr"/>
-          <a:lstStyle/>
-          <a:p>
-            <a:pPr indent="0" marL="0">
-              <a:buNone/>
-            </a:pPr>
-            <a:r>
-              <a:rPr lang="en-US" sz="1250" i="1" dirty="0">
-                <a:solidFill>
-                  <a:srgbClr val="FFB347"/>
-                </a:solidFill>
-                <a:latin typeface="Cambria" pitchFamily="34" charset="0"/>
-                <a:ea typeface="Cambria" pitchFamily="34" charset="-122"/>
-                <a:cs typeface="Cambria" pitchFamily="34" charset="-120"/>
-              </a:rPr>
-              <a:t>60% original tests · 25% review findings · 15% diff economy  →  one verdict, shown live</a:t>
-            </a:r>
-            <a:endParaRPr lang="en-US" sz="1250" dirty="0"/>
+              <a:t>The frontend holds zero fight logic — ten JSON events drive everything you see.</a:t>
+            </a:r>
+            <a:endParaRPr lang="en-US" sz="1500" dirty="0"/>
           </a:p>
         </p:txBody>
       </p:sp>

</xml_diff>